<commit_message>
Add follow-up runs: 200k-tick, drier, more leopards, stronger fire
18 runs (3 seeds each). Zebras evolved up to 2.8 mouths under drought but
food kept falling after they died, so no overgrazing suicide; 32 and 48
leopards crashed faster (48 ate the herd, then starved); 10x fire burnt
2.6x more but no fire passed 160 cells. Adds leopard-count world
variants, jobs-followup.js, follow-up figures, observation log for the
mechanism and follow-up runs, and a follow-up slide.
</commit_message>
<xml_diff>
--- a/presentation/Evolutionary-Suicide-LifeEngine.pptx
+++ b/presentation/Evolutionary-Suicide-LifeEngine.pptx
@@ -22,9 +22,10 @@
     <p:sldId id="270" r:id="rId16"/>
     <p:sldId id="271" r:id="rId17"/>
     <p:sldId id="272" r:id="rId18"/>
+    <p:sldId id="273" r:id="rId19"/>
   </p:sldIdLst>
   <p:notesMasterIdLst>
-    <p:notesMasterId r:id="rId19"/>
+    <p:notesMasterId r:id="rId20"/>
   </p:notesMasterIdLst>
   <p:sldSz cx="12192000" cy="6858000"/>
   <p:notesSz cx="6858000" cy="12192000"/>
@@ -123,45 +124,46 @@
   <p:extLst>
     <p:ext uri="{521415D9-36F7-43E2-AB2F-B90AF26B5E84}">
       <p14:sectionLst xmlns:p14="http://schemas.microsoft.com/office/powerpoint/2010/main">
-        <p14:section name="Introduction" id="{d3dc24ba-e481-f70a-950d-abc02bdd9a91}">
+        <p14:section name="Introduction" id="{29e763f6-5236-455e-23e7-15708c54151a}">
           <p14:sldIdLst>
             <p14:sldId id="256"/>
             <p14:sldId id="257"/>
             <p14:sldId id="258"/>
           </p14:sldIdLst>
         </p14:section>
-        <p14:section name="Base engine" id="{a5952423-d579-02a9-78a1-eae561938723}">
+        <p14:section name="Base engine" id="{19f4cf9a-bca5-9365-6b15-ca39514dda51}">
           <p14:sldIdLst>
             <p14:sldId id="259"/>
             <p14:sldId id="260"/>
             <p14:sldId id="261"/>
           </p14:sldIdLst>
         </p14:section>
-        <p14:section name="Modifications" id="{01cab5fb-3fb3-012d-f47f-8d9dbf9949d2}">
+        <p14:section name="Modifications" id="{dbff71cb-7536-2cb9-5627-cec475706552}">
           <p14:sldIdLst>
             <p14:sldId id="262"/>
             <p14:sldId id="263"/>
             <p14:sldId id="264"/>
           </p14:sldIdLst>
         </p14:section>
-        <p14:section name="Modified engine" id="{a3dc26d0-3bb9-bff6-34d1-4bb890e17237}">
+        <p14:section name="Modified engine" id="{022e0e7f-6ead-4322-ec5b-defce7eb80a6}">
           <p14:sldIdLst>
             <p14:sldId id="265"/>
             <p14:sldId id="266"/>
             <p14:sldId id="267"/>
           </p14:sldIdLst>
         </p14:section>
-        <p14:section name="Experiments" id="{0e8b1eee-0d5c-85bc-0b9f-daa071a4743c}">
+        <p14:section name="Experiments" id="{f268288b-1b3b-fd14-d047-46339bfcb2ca}">
           <p14:sldIdLst>
             <p14:sldId id="268"/>
             <p14:sldId id="269"/>
+            <p14:sldId id="270"/>
           </p14:sldIdLst>
         </p14:section>
-        <p14:section name="Conclusions" id="{f72d30ca-3be3-a6f0-bda3-002e2ef1c5d9}">
+        <p14:section name="Conclusions" id="{cfc5c2e7-8eef-9f52-5978-f3056c41d690}">
           <p14:sldIdLst>
-            <p14:sldId id="270"/>
             <p14:sldId id="271"/>
             <p14:sldId id="272"/>
+            <p14:sldId id="273"/>
           </p14:sldIdLst>
         </p14:section>
       </p14:sectionLst>
@@ -5512,7 +5514,7 @@
           <a:p>
             <a:r>
               <a:rPr lang="en-US" dirty="0"/>
-              <a:t>We seeded a savanna in the Life Engine and asked whether a species can adapt its way into extinction. We ran the unmodified engine and our modified savanna: 97 runs in total.</a:t>
+              <a:t>We seeded a savanna in the Life Engine and asked whether a species can adapt its way into extinction. We ran the unmodified engine and our modified savanna: 115 runs in total, including 18 follow-ups.</a:t>
             </a:r>
             <a:endParaRPr lang="en-US" dirty="0"/>
           </a:p>
@@ -6040,7 +6042,7 @@
           <a:p>
             <a:r>
               <a:rPr lang="en-US" dirty="0"/>
-              <a:t/>
+              <a:t>18 follow-up runs, 3 seeds each: 200k default, 200k dry, 32 and 48 leopards, strong and extreme fire. None produced zebra overgrazing suicide or a persistent predator.</a:t>
             </a:r>
             <a:endParaRPr lang="en-US" dirty="0"/>
           </a:p>
@@ -6240,6 +6242,94 @@
             <a:fld id="{F7021451-1387-4CA6-816F-3879F97B5CBC}" type="slidenum">
               <a:rPr lang="en-US"/>
               <a:t>17</a:t>
+            </a:fld>
+            <a:endParaRPr lang="en-US"/>
+          </a:p>
+        </p:txBody>
+      </p:sp>
+    </p:spTree>
+    <p:extLst>
+      <p:ext uri="{BB962C8B-B14F-4D97-AF65-F5344CB8AC3E}">
+        <p14:creationId xmlns:p14="http://schemas.microsoft.com/office/powerpoint/2010/main" val="1024086991"/>
+      </p:ext>
+    </p:extLst>
+  </p:cSld>
+  <p:clrMapOvr>
+    <a:masterClrMapping/>
+  </p:clrMapOvr>
+</p:notes>
+</file>
+
+<file path=ppt/notesSlides/notesSlide18.xml><?xml version="1.0" encoding="utf-8"?>
+<p:notes xmlns:a="http://schemas.openxmlformats.org/drawingml/2006/main" xmlns:r="http://schemas.openxmlformats.org/officeDocument/2006/relationships" xmlns:p="http://schemas.openxmlformats.org/presentationml/2006/main">
+  <p:cSld>
+    <p:spTree>
+      <p:nvGrpSpPr>
+        <p:cNvPr id="1" name=""/>
+        <p:cNvGrpSpPr/>
+        <p:nvPr/>
+      </p:nvGrpSpPr>
+      <p:grpSpPr>
+        <a:xfrm>
+          <a:off x="0" y="0"/>
+          <a:ext cx="0" cy="0"/>
+          <a:chOff x="0" y="0"/>
+          <a:chExt cx="0" cy="0"/>
+        </a:xfrm>
+      </p:grpSpPr>
+      <p:sp>
+        <p:nvSpPr>
+          <p:cNvPr id="2" name="Slide Image Placeholder 1"/>
+          <p:cNvSpPr>
+            <a:spLocks noGrp="1" noRot="1" noChangeAspect="1"/>
+          </p:cNvSpPr>
+          <p:nvPr>
+            <p:ph type="sldImg"/>
+          </p:nvPr>
+        </p:nvSpPr>
+        <p:spPr/>
+      </p:sp>
+      <p:sp>
+        <p:nvSpPr>
+          <p:cNvPr id="3" name="Notes Placeholder 2"/>
+          <p:cNvSpPr>
+            <a:spLocks noGrp="1"/>
+          </p:cNvSpPr>
+          <p:nvPr>
+            <p:ph type="body" idx="1"/>
+          </p:nvPr>
+        </p:nvSpPr>
+        <p:spPr/>
+        <p:txBody>
+          <a:bodyPr/>
+          <a:lstStyle/>
+          <a:p>
+            <a:r>
+              <a:rPr lang="en-US" dirty="0"/>
+              <a:t/>
+            </a:r>
+            <a:endParaRPr lang="en-US" dirty="0"/>
+          </a:p>
+        </p:txBody>
+      </p:sp>
+      <p:sp>
+        <p:nvSpPr>
+          <p:cNvPr id="4" name="Slide Number Placeholder 3"/>
+          <p:cNvSpPr>
+            <a:spLocks noGrp="1"/>
+          </p:cNvSpPr>
+          <p:nvPr>
+            <p:ph type="sldNum" sz="quarter" idx="10"/>
+          </p:nvPr>
+        </p:nvSpPr>
+        <p:spPr/>
+        <p:txBody>
+          <a:bodyPr/>
+          <a:lstStyle/>
+          <a:p>
+            <a:fld id="{F7021451-1387-4CA6-816F-3879F97B5CBC}" type="slidenum">
+              <a:rPr lang="en-US"/>
+              <a:t>18</a:t>
             </a:fld>
             <a:endParaRPr lang="en-US"/>
           </a:p>
@@ -7816,7 +7906,7 @@
                   <a:schemeClr val="accent1"/>
                 </a:solidFill>
               </a:rPr>
-              <a:t>Zebras, rhinos, leopards, grass and bushes in the Life Engine  ·  97 runs, base vs modified engine</a:t>
+              <a:t>Zebras, rhinos, leopards, grass and bushes in the Life Engine  ·  115 runs, base vs modified engine</a:t>
             </a:r>
             <a:endParaRPr lang="en-US" sz="2000" dirty="0"/>
           </a:p>
@@ -9230,7 +9320,7 @@
                   <a:schemeClr val="tx1"/>
                 </a:solidFill>
               </a:rPr>
-              <a:t>Answers to the brief</a:t>
+              <a:t>Longer, drier, more predators, more fire: same verdict</a:t>
             </a:r>
             <a:endParaRPr lang="en-US" sz="3000" dirty="0"/>
           </a:p>
@@ -9244,12 +9334,12 @@
         </p:nvSpPr>
         <p:spPr>
           <a:xfrm>
-            <a:off x="548640" y="1325880"/>
-            <a:ext cx="5440680" cy="2103120"/>
+            <a:off x="548640" y="1234440"/>
+            <a:ext cx="3520440" cy="1554480"/>
           </a:xfrm>
           <a:prstGeom prst="roundRect">
             <a:avLst>
-              <a:gd name="adj" fmla="val 5217"/>
+              <a:gd name="adj" fmla="val 7059"/>
             </a:avLst>
           </a:prstGeom>
           <a:solidFill>
@@ -9265,39 +9355,14 @@
       </p:sp>
       <p:sp>
         <p:nvSpPr>
-          <p:cNvPr id="4" name="Shape 2"/>
-          <p:cNvSpPr/>
-          <p:nvPr/>
-        </p:nvSpPr>
-        <p:spPr>
-          <a:xfrm>
-            <a:off x="822960" y="1600200"/>
-            <a:ext cx="457200" cy="457200"/>
-          </a:xfrm>
-          <a:prstGeom prst="ellipse">
-            <a:avLst/>
-          </a:prstGeom>
-          <a:solidFill>
-            <a:srgbClr val="D98E04"/>
-          </a:solidFill>
-          <a:ln w="12700">
-            <a:solidFill>
-              <a:srgbClr val="D98E04"/>
-            </a:solidFill>
-            <a:prstDash val="solid"/>
-          </a:ln>
-        </p:spPr>
-      </p:sp>
-      <p:sp>
-        <p:nvSpPr>
-          <p:cNvPr id="5" name="Text 3"/>
+          <p:cNvPr id="4" name="Text 2"/>
           <p:cNvSpPr txBox="1"/>
           <p:nvPr/>
         </p:nvSpPr>
         <p:spPr>
           <a:xfrm>
-            <a:off x="822960" y="1600200"/>
-            <a:ext cx="457200" cy="457200"/>
+            <a:off x="777240" y="1371600"/>
+            <a:ext cx="3108960" cy="411480"/>
           </a:xfrm>
           <a:prstGeom prst="rect">
             <a:avLst/>
@@ -9306,42 +9371,6 @@
           <a:ln/>
         </p:spPr>
         <p:txBody>
-          <a:bodyPr wrap="square" lIns="0" tIns="0" rIns="0" bIns="0" rtlCol="0" anchor="ctr"/>
-          <a:lstStyle/>
-          <a:p>
-            <a:pPr algn="ctr" indent="0" marL="0">
-              <a:buNone/>
-            </a:pPr>
-            <a:r>
-              <a:rPr lang="en-US" sz="1600" b="1" dirty="0">
-                <a:solidFill>
-                  <a:srgbClr val="FFFFFF"/>
-                </a:solidFill>
-              </a:rPr>
-              <a:t>1</a:t>
-            </a:r>
-            <a:endParaRPr lang="en-US" sz="1600" dirty="0"/>
-          </a:p>
-        </p:txBody>
-      </p:sp>
-      <p:sp>
-        <p:nvSpPr>
-          <p:cNvPr id="6" name="Text 4"/>
-          <p:cNvSpPr txBox="1"/>
-          <p:nvPr/>
-        </p:nvSpPr>
-        <p:spPr>
-          <a:xfrm>
-            <a:off x="1463040" y="1627632"/>
-            <a:ext cx="4297680" cy="457200"/>
-          </a:xfrm>
-          <a:prstGeom prst="rect">
-            <a:avLst/>
-          </a:prstGeom>
-          <a:noFill/>
-          <a:ln/>
-        </p:spPr>
-        <p:txBody>
           <a:bodyPr wrap="square" lIns="0" tIns="0" rIns="0" bIns="0" rtlCol="0" anchor="t"/>
           <a:lstStyle/>
           <a:p>
@@ -9349,7 +9378,7 @@
               <a:buNone/>
             </a:pPr>
             <a:r>
-              <a:rPr lang="en-US" sz="1900" b="1" dirty="0">
+              <a:rPr lang="en-US" sz="1800" b="1" dirty="0">
                 <a:solidFill>
                   <a:srgbClr val="1F1A14"/>
                 </a:solidFill>
@@ -9357,22 +9386,22 @@
                 <a:ea typeface="Cambria" pitchFamily="34" charset="-122"/>
                 <a:cs typeface="Cambria" pitchFamily="34" charset="-120"/>
               </a:rPr>
-              <a:t>Did extinction occur?</a:t>
-            </a:r>
-            <a:endParaRPr lang="en-US" sz="1900" dirty="0"/>
-          </a:p>
-        </p:txBody>
-      </p:sp>
-      <p:sp>
-        <p:nvSpPr>
-          <p:cNvPr id="7" name="Text 5"/>
+              <a:t>200k ticks, 40% rain</a:t>
+            </a:r>
+            <a:endParaRPr lang="en-US" sz="1800" dirty="0"/>
+          </a:p>
+        </p:txBody>
+      </p:sp>
+      <p:sp>
+        <p:nvSpPr>
+          <p:cNvPr id="5" name="Text 3"/>
           <p:cNvSpPr txBox="1"/>
           <p:nvPr/>
         </p:nvSpPr>
         <p:spPr>
           <a:xfrm>
-            <a:off x="822960" y="2240280"/>
-            <a:ext cx="4937760" cy="1280160"/>
+            <a:off x="777240" y="1828800"/>
+            <a:ext cx="3108960" cy="914400"/>
           </a:xfrm>
           <a:prstGeom prst="rect">
             <a:avLst/>
@@ -9388,31 +9417,31 @@
               <a:buNone/>
             </a:pPr>
             <a:r>
-              <a:rPr lang="en-US" sz="1500" dirty="0">
+              <a:rPr lang="en-US" sz="1300" dirty="0">
                 <a:solidFill>
                   <a:srgbClr val="1F1A14"/>
                 </a:solidFill>
               </a:rPr>
-              <a:t>Yes: every leopard and rhino population in the main runs, and zebras in 4 of 5 main seeds.</a:t>
-            </a:r>
-            <a:endParaRPr lang="en-US" sz="1500" dirty="0"/>
-          </a:p>
-        </p:txBody>
-      </p:sp>
-      <p:sp>
-        <p:nvSpPr>
-          <p:cNvPr id="8" name="Shape 6"/>
+              <a:t>Zebras evolved up to 2.8 mouths as food fell, then died out. Food kept falling after they were gone: grass crowding, not grazing.</a:t>
+            </a:r>
+            <a:endParaRPr lang="en-US" sz="1300" dirty="0"/>
+          </a:p>
+        </p:txBody>
+      </p:sp>
+      <p:sp>
+        <p:nvSpPr>
+          <p:cNvPr id="6" name="Shape 4"/>
           <p:cNvSpPr/>
           <p:nvPr/>
         </p:nvSpPr>
         <p:spPr>
           <a:xfrm>
-            <a:off x="6172200" y="1325880"/>
-            <a:ext cx="5440680" cy="2103120"/>
+            <a:off x="4297680" y="1234440"/>
+            <a:ext cx="3520440" cy="1554480"/>
           </a:xfrm>
           <a:prstGeom prst="roundRect">
             <a:avLst>
-              <a:gd name="adj" fmla="val 5217"/>
+              <a:gd name="adj" fmla="val 7059"/>
             </a:avLst>
           </a:prstGeom>
           <a:solidFill>
@@ -9428,39 +9457,14 @@
       </p:sp>
       <p:sp>
         <p:nvSpPr>
-          <p:cNvPr id="9" name="Shape 7"/>
-          <p:cNvSpPr/>
-          <p:nvPr/>
-        </p:nvSpPr>
-        <p:spPr>
-          <a:xfrm>
-            <a:off x="6446520" y="1600200"/>
-            <a:ext cx="457200" cy="457200"/>
-          </a:xfrm>
-          <a:prstGeom prst="ellipse">
-            <a:avLst/>
-          </a:prstGeom>
-          <a:solidFill>
-            <a:srgbClr val="D98E04"/>
-          </a:solidFill>
-          <a:ln w="12700">
-            <a:solidFill>
-              <a:srgbClr val="D98E04"/>
-            </a:solidFill>
-            <a:prstDash val="solid"/>
-          </a:ln>
-        </p:spPr>
-      </p:sp>
-      <p:sp>
-        <p:nvSpPr>
-          <p:cNvPr id="10" name="Text 8"/>
+          <p:cNvPr id="7" name="Text 5"/>
           <p:cNvSpPr txBox="1"/>
           <p:nvPr/>
         </p:nvSpPr>
         <p:spPr>
           <a:xfrm>
-            <a:off x="6446520" y="1600200"/>
-            <a:ext cx="457200" cy="457200"/>
+            <a:off x="4526280" y="1371600"/>
+            <a:ext cx="3108960" cy="411480"/>
           </a:xfrm>
           <a:prstGeom prst="rect">
             <a:avLst/>
@@ -9469,42 +9473,6 @@
           <a:ln/>
         </p:spPr>
         <p:txBody>
-          <a:bodyPr wrap="square" lIns="0" tIns="0" rIns="0" bIns="0" rtlCol="0" anchor="ctr"/>
-          <a:lstStyle/>
-          <a:p>
-            <a:pPr algn="ctr" indent="0" marL="0">
-              <a:buNone/>
-            </a:pPr>
-            <a:r>
-              <a:rPr lang="en-US" sz="1600" b="1" dirty="0">
-                <a:solidFill>
-                  <a:srgbClr val="FFFFFF"/>
-                </a:solidFill>
-              </a:rPr>
-              <a:t>2</a:t>
-            </a:r>
-            <a:endParaRPr lang="en-US" sz="1600" dirty="0"/>
-          </a:p>
-        </p:txBody>
-      </p:sp>
-      <p:sp>
-        <p:nvSpPr>
-          <p:cNvPr id="11" name="Text 9"/>
-          <p:cNvSpPr txBox="1"/>
-          <p:nvPr/>
-        </p:nvSpPr>
-        <p:spPr>
-          <a:xfrm>
-            <a:off x="7086600" y="1627632"/>
-            <a:ext cx="4297680" cy="457200"/>
-          </a:xfrm>
-          <a:prstGeom prst="rect">
-            <a:avLst/>
-          </a:prstGeom>
-          <a:noFill/>
-          <a:ln/>
-        </p:spPr>
-        <p:txBody>
           <a:bodyPr wrap="square" lIns="0" tIns="0" rIns="0" bIns="0" rtlCol="0" anchor="t"/>
           <a:lstStyle/>
           <a:p>
@@ -9512,30 +9480,30 @@
               <a:buNone/>
             </a:pPr>
             <a:r>
-              <a:rPr lang="en-US" sz="1900" b="1" dirty="0">
-                <a:solidFill>
-                  <a:srgbClr val="1F1A14"/>
+              <a:rPr lang="en-US" sz="1800" b="1" dirty="0">
+                <a:solidFill>
+                  <a:srgbClr val="D98E04"/>
                 </a:solidFill>
                 <a:latin typeface="Cambria" pitchFamily="34" charset="0"/>
                 <a:ea typeface="Cambria" pitchFamily="34" charset="-122"/>
                 <a:cs typeface="Cambria" pitchFamily="34" charset="-120"/>
               </a:rPr>
-              <a:t>Suicide or failure?</a:t>
-            </a:r>
-            <a:endParaRPr lang="en-US" sz="1900" dirty="0"/>
-          </a:p>
-        </p:txBody>
-      </p:sp>
-      <p:sp>
-        <p:nvSpPr>
-          <p:cNvPr id="12" name="Text 10"/>
+              <a:t>32 and 48 leopards</a:t>
+            </a:r>
+            <a:endParaRPr lang="en-US" sz="1800" dirty="0"/>
+          </a:p>
+        </p:txBody>
+      </p:sp>
+      <p:sp>
+        <p:nvSpPr>
+          <p:cNvPr id="8" name="Text 6"/>
           <p:cNvSpPr txBox="1"/>
           <p:nvPr/>
         </p:nvSpPr>
         <p:spPr>
           <a:xfrm>
-            <a:off x="6446520" y="2240280"/>
-            <a:ext cx="4937760" cy="1280160"/>
+            <a:off x="4526280" y="1828800"/>
+            <a:ext cx="3108960" cy="914400"/>
           </a:xfrm>
           <a:prstGeom prst="rect">
             <a:avLst/>
@@ -9551,31 +9519,31 @@
               <a:buNone/>
             </a:pPr>
             <a:r>
-              <a:rPr lang="en-US" sz="1500" dirty="0">
+              <a:rPr lang="en-US" sz="1300" dirty="0">
                 <a:solidFill>
                   <a:srgbClr val="1F1A14"/>
                 </a:solidFill>
               </a:rPr>
-              <a:t>Suicide in the base engine (evolved plant-killers, 3 of 3). Failure to adapt for rhinos and non-adapting zebras; boom-bust for leopards.</a:t>
-            </a:r>
-            <a:endParaRPr lang="en-US" sz="1500" dirty="0"/>
-          </a:p>
-        </p:txBody>
-      </p:sp>
-      <p:sp>
-        <p:nvSpPr>
-          <p:cNvPr id="13" name="Shape 11"/>
+              <a:t>48 leopards ate the whole herd in about 1,300 ticks, then starved: over-exploitation from density, not an evolved trait.</a:t>
+            </a:r>
+            <a:endParaRPr lang="en-US" sz="1300" dirty="0"/>
+          </a:p>
+        </p:txBody>
+      </p:sp>
+      <p:sp>
+        <p:nvSpPr>
+          <p:cNvPr id="9" name="Shape 7"/>
           <p:cNvSpPr/>
           <p:nvPr/>
         </p:nvSpPr>
         <p:spPr>
           <a:xfrm>
-            <a:off x="548640" y="3657600"/>
-            <a:ext cx="5440680" cy="2103120"/>
+            <a:off x="8046720" y="1234440"/>
+            <a:ext cx="3520440" cy="1554480"/>
           </a:xfrm>
           <a:prstGeom prst="roundRect">
             <a:avLst>
-              <a:gd name="adj" fmla="val 5217"/>
+              <a:gd name="adj" fmla="val 7059"/>
             </a:avLst>
           </a:prstGeom>
           <a:solidFill>
@@ -9591,39 +9559,14 @@
       </p:sp>
       <p:sp>
         <p:nvSpPr>
-          <p:cNvPr id="14" name="Shape 12"/>
-          <p:cNvSpPr/>
-          <p:nvPr/>
-        </p:nvSpPr>
-        <p:spPr>
-          <a:xfrm>
-            <a:off x="822960" y="3931920"/>
-            <a:ext cx="457200" cy="457200"/>
-          </a:xfrm>
-          <a:prstGeom prst="ellipse">
-            <a:avLst/>
-          </a:prstGeom>
-          <a:solidFill>
-            <a:srgbClr val="D98E04"/>
-          </a:solidFill>
-          <a:ln w="12700">
-            <a:solidFill>
-              <a:srgbClr val="D98E04"/>
-            </a:solidFill>
-            <a:prstDash val="solid"/>
-          </a:ln>
-        </p:spPr>
-      </p:sp>
-      <p:sp>
-        <p:nvSpPr>
-          <p:cNvPr id="15" name="Text 13"/>
+          <p:cNvPr id="10" name="Text 8"/>
           <p:cNvSpPr txBox="1"/>
           <p:nvPr/>
         </p:nvSpPr>
         <p:spPr>
           <a:xfrm>
-            <a:off x="822960" y="3931920"/>
-            <a:ext cx="457200" cy="457200"/>
+            <a:off x="8275320" y="1371600"/>
+            <a:ext cx="3108960" cy="411480"/>
           </a:xfrm>
           <a:prstGeom prst="rect">
             <a:avLst/>
@@ -9632,42 +9575,6 @@
           <a:ln/>
         </p:spPr>
         <p:txBody>
-          <a:bodyPr wrap="square" lIns="0" tIns="0" rIns="0" bIns="0" rtlCol="0" anchor="ctr"/>
-          <a:lstStyle/>
-          <a:p>
-            <a:pPr algn="ctr" indent="0" marL="0">
-              <a:buNone/>
-            </a:pPr>
-            <a:r>
-              <a:rPr lang="en-US" sz="1600" b="1" dirty="0">
-                <a:solidFill>
-                  <a:srgbClr val="FFFFFF"/>
-                </a:solidFill>
-              </a:rPr>
-              <a:t>3</a:t>
-            </a:r>
-            <a:endParaRPr lang="en-US" sz="1600" dirty="0"/>
-          </a:p>
-        </p:txBody>
-      </p:sp>
-      <p:sp>
-        <p:nvSpPr>
-          <p:cNvPr id="16" name="Text 14"/>
-          <p:cNvSpPr txBox="1"/>
-          <p:nvPr/>
-        </p:nvSpPr>
-        <p:spPr>
-          <a:xfrm>
-            <a:off x="1463040" y="3959352"/>
-            <a:ext cx="4297680" cy="457200"/>
-          </a:xfrm>
-          <a:prstGeom prst="rect">
-            <a:avLst/>
-          </a:prstGeom>
-          <a:noFill/>
-          <a:ln/>
-        </p:spPr>
-        <p:txBody>
           <a:bodyPr wrap="square" lIns="0" tIns="0" rIns="0" bIns="0" rtlCol="0" anchor="t"/>
           <a:lstStyle/>
           <a:p>
@@ -9675,30 +9582,30 @@
               <a:buNone/>
             </a:pPr>
             <a:r>
-              <a:rPr lang="en-US" sz="1900" b="1" dirty="0">
-                <a:solidFill>
-                  <a:srgbClr val="1F1A14"/>
+              <a:rPr lang="en-US" sz="1800" b="1" dirty="0">
+                <a:solidFill>
+                  <a:srgbClr val="B23A3A"/>
                 </a:solidFill>
                 <a:latin typeface="Cambria" pitchFamily="34" charset="0"/>
                 <a:ea typeface="Cambria" pitchFamily="34" charset="-122"/>
                 <a:cs typeface="Cambria" pitchFamily="34" charset="-120"/>
               </a:rPr>
-              <a:t>Environment or species?</a:t>
-            </a:r>
-            <a:endParaRPr lang="en-US" sz="1900" dirty="0"/>
-          </a:p>
-        </p:txBody>
-      </p:sp>
-      <p:sp>
-        <p:nvSpPr>
-          <p:cNvPr id="17" name="Text 15"/>
+              <a:t>10x fire chance</a:t>
+            </a:r>
+            <a:endParaRPr lang="en-US" sz="1800" dirty="0"/>
+          </a:p>
+        </p:txBody>
+      </p:sp>
+      <p:sp>
+        <p:nvSpPr>
+          <p:cNvPr id="11" name="Text 9"/>
           <p:cNvSpPr txBox="1"/>
           <p:nvPr/>
         </p:nvSpPr>
         <p:spPr>
           <a:xfrm>
-            <a:off x="822960" y="4572000"/>
-            <a:ext cx="4937760" cy="1280160"/>
+            <a:off x="8275320" y="1828800"/>
+            <a:ext cx="3108960" cy="914400"/>
           </a:xfrm>
           <a:prstGeom prst="rect">
             <a:avLst/>
@@ -9714,180 +9621,65 @@
               <a:buNone/>
             </a:pPr>
             <a:r>
-              <a:rPr lang="en-US" sz="1500" dirty="0">
+              <a:rPr lang="en-US" sz="1300" dirty="0">
                 <a:solidFill>
                   <a:srgbClr val="1F1A14"/>
                 </a:solidFill>
               </a:rPr>
-              <a:t>The same zebras killed themselves in the base engine and adapted in the savanna. Removing the river or soil water was as decisive as removing a trait.</a:t>
-            </a:r>
-            <a:endParaRPr lang="en-US" sz="1500" dirty="0"/>
-          </a:p>
-        </p:txBody>
-      </p:sp>
-      <p:sp>
-        <p:nvSpPr>
-          <p:cNvPr id="18" name="Shape 16"/>
-          <p:cNvSpPr/>
-          <p:nvPr/>
-        </p:nvSpPr>
-        <p:spPr>
-          <a:xfrm>
-            <a:off x="6172200" y="3657600"/>
-            <a:ext cx="5440680" cy="2103120"/>
-          </a:xfrm>
-          <a:prstGeom prst="roundRect">
-            <a:avLst>
-              <a:gd name="adj" fmla="val 5217"/>
-            </a:avLst>
-          </a:prstGeom>
-          <a:solidFill>
-            <a:srgbClr val="F1F3F2"/>
-          </a:solidFill>
-          <a:ln w="12700">
-            <a:solidFill>
-              <a:srgbClr val="F1F3F2"/>
-            </a:solidFill>
-            <a:prstDash val="solid"/>
-          </a:ln>
-        </p:spPr>
-      </p:sp>
-      <p:sp>
-        <p:nvSpPr>
-          <p:cNvPr id="19" name="Shape 17"/>
-          <p:cNvSpPr/>
-          <p:nvPr/>
-        </p:nvSpPr>
-        <p:spPr>
-          <a:xfrm>
-            <a:off x="6446520" y="3931920"/>
-            <a:ext cx="457200" cy="457200"/>
-          </a:xfrm>
-          <a:prstGeom prst="ellipse">
-            <a:avLst/>
-          </a:prstGeom>
-          <a:solidFill>
-            <a:srgbClr val="D98E04"/>
-          </a:solidFill>
-          <a:ln w="12700">
-            <a:solidFill>
-              <a:srgbClr val="D98E04"/>
-            </a:solidFill>
-            <a:prstDash val="solid"/>
-          </a:ln>
-        </p:spPr>
-      </p:sp>
-      <p:sp>
-        <p:nvSpPr>
-          <p:cNvPr id="20" name="Text 18"/>
-          <p:cNvSpPr txBox="1"/>
-          <p:nvPr/>
-        </p:nvSpPr>
-        <p:spPr>
-          <a:xfrm>
-            <a:off x="6446520" y="3931920"/>
-            <a:ext cx="457200" cy="457200"/>
-          </a:xfrm>
-          <a:prstGeom prst="rect">
-            <a:avLst/>
-          </a:prstGeom>
-          <a:noFill/>
-          <a:ln/>
-        </p:spPr>
-        <p:txBody>
-          <a:bodyPr wrap="square" lIns="0" tIns="0" rIns="0" bIns="0" rtlCol="0" anchor="ctr"/>
-          <a:lstStyle/>
-          <a:p>
-            <a:pPr algn="ctr" indent="0" marL="0">
-              <a:buNone/>
-            </a:pPr>
-            <a:r>
-              <a:rPr lang="en-US" sz="1600" b="1" dirty="0">
-                <a:solidFill>
-                  <a:srgbClr val="FFFFFF"/>
-                </a:solidFill>
-              </a:rPr>
-              <a:t>4</a:t>
-            </a:r>
-            <a:endParaRPr lang="en-US" sz="1600" dirty="0"/>
-          </a:p>
-        </p:txBody>
-      </p:sp>
-      <p:sp>
-        <p:nvSpPr>
-          <p:cNvPr id="21" name="Text 19"/>
-          <p:cNvSpPr txBox="1"/>
-          <p:nvPr/>
-        </p:nvSpPr>
-        <p:spPr>
-          <a:xfrm>
-            <a:off x="7086600" y="3959352"/>
-            <a:ext cx="4297680" cy="457200"/>
-          </a:xfrm>
-          <a:prstGeom prst="rect">
-            <a:avLst/>
-          </a:prstGeom>
-          <a:noFill/>
-          <a:ln/>
-        </p:spPr>
-        <p:txBody>
-          <a:bodyPr wrap="square" lIns="0" tIns="0" rIns="0" bIns="0" rtlCol="0" anchor="t"/>
-          <a:lstStyle/>
-          <a:p>
-            <a:pPr indent="0" marL="0">
-              <a:buNone/>
-            </a:pPr>
-            <a:r>
-              <a:rPr lang="en-US" sz="1900" b="1" dirty="0">
-                <a:solidFill>
-                  <a:srgbClr val="1F1A14"/>
-                </a:solidFill>
-                <a:latin typeface="Cambria" pitchFamily="34" charset="0"/>
-                <a:ea typeface="Cambria" pitchFamily="34" charset="-122"/>
-                <a:cs typeface="Cambria" pitchFamily="34" charset="-120"/>
-              </a:rPr>
-              <a:t>Instrumental traits</a:t>
-            </a:r>
-            <a:endParaRPr lang="en-US" sz="1900" dirty="0"/>
-          </a:p>
-        </p:txBody>
-      </p:sp>
-      <p:sp>
-        <p:nvSpPr>
-          <p:cNvPr id="22" name="Text 20"/>
-          <p:cNvSpPr txBox="1"/>
-          <p:nvPr/>
-        </p:nvSpPr>
-        <p:spPr>
-          <a:xfrm>
-            <a:off x="6446520" y="4572000"/>
-            <a:ext cx="4937760" cy="1280160"/>
-          </a:xfrm>
-          <a:prstGeom prst="rect">
-            <a:avLst/>
-          </a:prstGeom>
-          <a:noFill/>
-          <a:ln/>
-        </p:spPr>
-        <p:txBody>
-          <a:bodyPr wrap="square" lIns="0" tIns="0" rIns="0" bIns="0" rtlCol="0" anchor="t"/>
-          <a:lstStyle/>
-          <a:p>
-            <a:pPr indent="0" marL="0">
-              <a:buNone/>
-            </a:pPr>
-            <a:r>
-              <a:rPr lang="en-US" sz="1500" dirty="0">
-                <a:solidFill>
-                  <a:srgbClr val="1F1A14"/>
-                </a:solidFill>
-              </a:rPr>
-              <a:t>Toward collapse: evolved killers, costly armour, single-prey diet. Away: river, water regrowth, stripes, kick, the second mouth.</a:t>
-            </a:r>
-            <a:endParaRPr lang="en-US" sz="1500" dirty="0"/>
-          </a:p>
-        </p:txBody>
-      </p:sp>
+              <a:t>Burning rose only 2.6x and no fire passed 160 cells. Patchy plants on wet soil starve fires of fuel.</a:t>
+            </a:r>
+            <a:endParaRPr lang="en-US" sz="1300" dirty="0"/>
+          </a:p>
+        </p:txBody>
+      </p:sp>
+      <p:pic>
+        <p:nvPicPr>
+          <p:cNvPr id="12" name="Image 0" descr="C:/Users/Ashley/Documents/LifeEngine/savanna-experiments/output/figures/timeline-long-dry-3.png">    </p:cNvPr>
+          <p:cNvPicPr>
+            <a:picLocks noChangeAspect="1"/>
+          </p:cNvPicPr>
+          <p:nvPr/>
+        </p:nvPicPr>
+        <p:blipFill>
+          <a:blip r:embed="rId1"/>
+          <a:stretch>
+            <a:fillRect/>
+          </a:stretch>
+        </p:blipFill>
+        <p:spPr>
+          <a:xfrm>
+            <a:off x="548640" y="3017520"/>
+            <a:ext cx="5440680" cy="2742565"/>
+          </a:xfrm>
+          <a:prstGeom prst="rect">
+            <a:avLst/>
+          </a:prstGeom>
+        </p:spPr>
+      </p:pic>
+      <p:pic>
+        <p:nvPicPr>
+          <p:cNvPr id="13" name="Image 1" descr="C:/Users/Ashley/Documents/LifeEngine/savanna-experiments/output/figures/timeline-leopards48.png">    </p:cNvPr>
+          <p:cNvPicPr>
+            <a:picLocks noChangeAspect="1"/>
+          </p:cNvPicPr>
+          <p:nvPr/>
+        </p:nvPicPr>
+        <p:blipFill>
+          <a:blip r:embed="rId2"/>
+          <a:stretch>
+            <a:fillRect/>
+          </a:stretch>
+        </p:blipFill>
+        <p:spPr>
+          <a:xfrm>
+            <a:off x="6172200" y="3017520"/>
+            <a:ext cx="5440680" cy="2742565"/>
+          </a:xfrm>
+          <a:prstGeom prst="rect">
+            <a:avLst/>
+          </a:prstGeom>
+        </p:spPr>
+      </p:pic>
       <p:sp>
         <p:nvSpPr>
           <p:cNvPr id="25" name="Slide Number Placeholder 0"/>
@@ -9990,7 +9782,7 @@
                   <a:schemeClr val="tx1"/>
                 </a:solidFill>
               </a:rPr>
-              <a:t>What we can and cannot claim</a:t>
+              <a:t>Answers to the brief</a:t>
             </a:r>
             <a:endParaRPr lang="en-US" sz="3000" dirty="0"/>
           </a:p>
@@ -10004,20 +9796,20 @@
         </p:nvSpPr>
         <p:spPr>
           <a:xfrm>
-            <a:off x="548640" y="1280160"/>
-            <a:ext cx="5394960" cy="3840480"/>
+            <a:off x="548640" y="1325880"/>
+            <a:ext cx="5440680" cy="2103120"/>
           </a:xfrm>
           <a:prstGeom prst="roundRect">
             <a:avLst>
-              <a:gd name="adj" fmla="val 2857"/>
+              <a:gd name="adj" fmla="val 5217"/>
             </a:avLst>
           </a:prstGeom>
           <a:solidFill>
-            <a:srgbClr val="F8ECEC"/>
+            <a:srgbClr val="F1F3F2"/>
           </a:solidFill>
           <a:ln w="12700">
             <a:solidFill>
-              <a:srgbClr val="F8ECEC"/>
+              <a:srgbClr val="F1F3F2"/>
             </a:solidFill>
             <a:prstDash val="solid"/>
           </a:ln>
@@ -10025,14 +9817,39 @@
       </p:sp>
       <p:sp>
         <p:nvSpPr>
-          <p:cNvPr id="4" name="Text 2"/>
+          <p:cNvPr id="4" name="Shape 2"/>
+          <p:cNvSpPr/>
+          <p:nvPr/>
+        </p:nvSpPr>
+        <p:spPr>
+          <a:xfrm>
+            <a:off x="822960" y="1600200"/>
+            <a:ext cx="457200" cy="457200"/>
+          </a:xfrm>
+          <a:prstGeom prst="ellipse">
+            <a:avLst/>
+          </a:prstGeom>
+          <a:solidFill>
+            <a:srgbClr val="D98E04"/>
+          </a:solidFill>
+          <a:ln w="12700">
+            <a:solidFill>
+              <a:srgbClr val="D98E04"/>
+            </a:solidFill>
+            <a:prstDash val="solid"/>
+          </a:ln>
+        </p:spPr>
+      </p:sp>
+      <p:sp>
+        <p:nvSpPr>
+          <p:cNvPr id="5" name="Text 3"/>
           <p:cNvSpPr txBox="1"/>
           <p:nvPr/>
         </p:nvSpPr>
         <p:spPr>
           <a:xfrm>
-            <a:off x="822960" y="1463040"/>
-            <a:ext cx="4846320" cy="457200"/>
+            <a:off x="822960" y="1600200"/>
+            <a:ext cx="457200" cy="457200"/>
           </a:xfrm>
           <a:prstGeom prst="rect">
             <a:avLst/>
@@ -10041,6 +9858,42 @@
           <a:ln/>
         </p:spPr>
         <p:txBody>
+          <a:bodyPr wrap="square" lIns="0" tIns="0" rIns="0" bIns="0" rtlCol="0" anchor="ctr"/>
+          <a:lstStyle/>
+          <a:p>
+            <a:pPr algn="ctr" indent="0" marL="0">
+              <a:buNone/>
+            </a:pPr>
+            <a:r>
+              <a:rPr lang="en-US" sz="1600" b="1" dirty="0">
+                <a:solidFill>
+                  <a:srgbClr val="FFFFFF"/>
+                </a:solidFill>
+              </a:rPr>
+              <a:t>1</a:t>
+            </a:r>
+            <a:endParaRPr lang="en-US" sz="1600" dirty="0"/>
+          </a:p>
+        </p:txBody>
+      </p:sp>
+      <p:sp>
+        <p:nvSpPr>
+          <p:cNvPr id="6" name="Text 4"/>
+          <p:cNvSpPr txBox="1"/>
+          <p:nvPr/>
+        </p:nvSpPr>
+        <p:spPr>
+          <a:xfrm>
+            <a:off x="1463040" y="1627632"/>
+            <a:ext cx="4297680" cy="457200"/>
+          </a:xfrm>
+          <a:prstGeom prst="rect">
+            <a:avLst/>
+          </a:prstGeom>
+          <a:noFill/>
+          <a:ln/>
+        </p:spPr>
+        <p:txBody>
           <a:bodyPr wrap="square" lIns="0" tIns="0" rIns="0" bIns="0" rtlCol="0" anchor="t"/>
           <a:lstStyle/>
           <a:p>
@@ -10048,30 +9901,30 @@
               <a:buNone/>
             </a:pPr>
             <a:r>
-              <a:rPr lang="en-US" sz="2000" b="1" dirty="0">
-                <a:solidFill>
-                  <a:srgbClr val="B23A3A"/>
+              <a:rPr lang="en-US" sz="1900" b="1" dirty="0">
+                <a:solidFill>
+                  <a:srgbClr val="1F1A14"/>
                 </a:solidFill>
                 <a:latin typeface="Cambria" pitchFamily="34" charset="0"/>
                 <a:ea typeface="Cambria" pitchFamily="34" charset="-122"/>
                 <a:cs typeface="Cambria" pitchFamily="34" charset="-120"/>
               </a:rPr>
-              <a:t>Limits</a:t>
-            </a:r>
-            <a:endParaRPr lang="en-US" sz="2000" dirty="0"/>
-          </a:p>
-        </p:txBody>
-      </p:sp>
-      <p:sp>
-        <p:nvSpPr>
-          <p:cNvPr id="5" name="Text 3"/>
+              <a:t>Did extinction occur?</a:t>
+            </a:r>
+            <a:endParaRPr lang="en-US" sz="1900" dirty="0"/>
+          </a:p>
+        </p:txBody>
+      </p:sp>
+      <p:sp>
+        <p:nvSpPr>
+          <p:cNvPr id="7" name="Text 5"/>
           <p:cNvSpPr txBox="1"/>
           <p:nvPr/>
         </p:nvSpPr>
         <p:spPr>
           <a:xfrm>
-            <a:off x="822960" y="2011680"/>
-            <a:ext cx="4846320" cy="3840480"/>
+            <a:off x="822960" y="2240280"/>
+            <a:ext cx="4937760" cy="1280160"/>
           </a:xfrm>
           <a:prstGeom prst="rect">
             <a:avLst/>
@@ -10083,12 +9936,8 @@
           <a:bodyPr wrap="square" lIns="0" tIns="0" rIns="0" bIns="0" rtlCol="0" anchor="t"/>
           <a:lstStyle/>
           <a:p>
-            <a:pPr marL="342900" indent="-342900">
-              <a:spcAft>
-                <a:spcPts val="800"/>
-              </a:spcAft>
-              <a:buSzPct val="100000"/>
-              <a:buChar char="•"/>
+            <a:pPr indent="0" marL="0">
+              <a:buNone/>
             </a:pPr>
             <a:r>
               <a:rPr lang="en-US" sz="1500" dirty="0">
@@ -10096,88 +9945,34 @@
                   <a:srgbClr val="1F1A14"/>
                 </a:solidFill>
               </a:rPr>
-              <a:t>3 seeds per ablation and sweep: one seed of difference is noise</a:t>
+              <a:t>Yes: every leopard and rhino population in the main runs, and zebras in 4 of 5 main seeds.</a:t>
             </a:r>
             <a:endParaRPr lang="en-US" sz="1500" dirty="0"/>
           </a:p>
-          <a:p>
-            <a:pPr marL="342900" indent="-342900">
-              <a:spcAft>
-                <a:spcPts val="800"/>
-              </a:spcAft>
-              <a:buSzPct val="100000"/>
-              <a:buChar char="•"/>
-            </a:pPr>
-            <a:r>
-              <a:rPr lang="en-US" sz="1500" dirty="0">
-                <a:solidFill>
-                  <a:srgbClr val="1F1A14"/>
-                </a:solidFill>
-              </a:rPr>
-              <a:t>Rules were rebalanced during testing (leopard body, sprint, armour, weapons) before the final runs</a:t>
-            </a:r>
-            <a:endParaRPr lang="en-US" sz="1500" dirty="0"/>
-          </a:p>
-          <a:p>
-            <a:pPr marL="342900" indent="-342900">
-              <a:spcAft>
-                <a:spcPts val="800"/>
-              </a:spcAft>
-              <a:buSzPct val="100000"/>
-              <a:buChar char="•"/>
-            </a:pPr>
-            <a:r>
-              <a:rPr lang="en-US" sz="1500" dirty="0">
-                <a:solidFill>
-                  <a:srgbClr val="1F1A14"/>
-                </a:solidFill>
-              </a:rPr>
-              <a:t>Our overgrazing hypothesis was not observed in 100k ticks</a:t>
-            </a:r>
-            <a:endParaRPr lang="en-US" sz="1500" dirty="0"/>
-          </a:p>
-          <a:p>
-            <a:pPr marL="342900" indent="-342900">
-              <a:spcAft>
-                <a:spcPts val="800"/>
-              </a:spcAft>
-              <a:buSzPct val="100000"/>
-              <a:buChar char="•"/>
-            </a:pPr>
-            <a:r>
-              <a:rPr lang="en-US" sz="1500" dirty="0">
-                <a:solidFill>
-                  <a:srgbClr val="1F1A14"/>
-                </a:solidFill>
-              </a:rPr>
-              <a:t>Fires stayed small; 16 leopards never persisted</a:t>
-            </a:r>
-            <a:endParaRPr lang="en-US" sz="1500" dirty="0"/>
-          </a:p>
-        </p:txBody>
-      </p:sp>
-      <p:sp>
-        <p:nvSpPr>
-          <p:cNvPr id="6" name="Shape 4"/>
+        </p:txBody>
+      </p:sp>
+      <p:sp>
+        <p:nvSpPr>
+          <p:cNvPr id="8" name="Shape 6"/>
           <p:cNvSpPr/>
           <p:nvPr/>
         </p:nvSpPr>
         <p:spPr>
           <a:xfrm>
-            <a:off x="6217920" y="1280160"/>
-            <a:ext cx="5394960" cy="3840480"/>
+            <a:off x="6172200" y="1325880"/>
+            <a:ext cx="5440680" cy="2103120"/>
           </a:xfrm>
           <a:prstGeom prst="roundRect">
             <a:avLst>
-              <a:gd name="adj" fmla="val 2857"/>
+              <a:gd name="adj" fmla="val 5217"/>
             </a:avLst>
           </a:prstGeom>
           <a:solidFill>
-            <a:srgbClr val="EEF5EA"/>
+            <a:srgbClr val="F1F3F2"/>
           </a:solidFill>
           <a:ln w="12700">
             <a:solidFill>
-              <a:srgbClr val="EEF5EA"/>
+              <a:srgbClr val="F1F3F2"/>
             </a:solidFill>
             <a:prstDash val="solid"/>
           </a:ln>
@@ -10185,14 +9980,39 @@
       </p:sp>
       <p:sp>
         <p:nvSpPr>
-          <p:cNvPr id="7" name="Text 5"/>
+          <p:cNvPr id="9" name="Shape 7"/>
+          <p:cNvSpPr/>
+          <p:nvPr/>
+        </p:nvSpPr>
+        <p:spPr>
+          <a:xfrm>
+            <a:off x="6446520" y="1600200"/>
+            <a:ext cx="457200" cy="457200"/>
+          </a:xfrm>
+          <a:prstGeom prst="ellipse">
+            <a:avLst/>
+          </a:prstGeom>
+          <a:solidFill>
+            <a:srgbClr val="D98E04"/>
+          </a:solidFill>
+          <a:ln w="12700">
+            <a:solidFill>
+              <a:srgbClr val="D98E04"/>
+            </a:solidFill>
+            <a:prstDash val="solid"/>
+          </a:ln>
+        </p:spPr>
+      </p:sp>
+      <p:sp>
+        <p:nvSpPr>
+          <p:cNvPr id="10" name="Text 8"/>
           <p:cNvSpPr txBox="1"/>
           <p:nvPr/>
         </p:nvSpPr>
         <p:spPr>
           <a:xfrm>
-            <a:off x="6492240" y="1463040"/>
-            <a:ext cx="4846320" cy="457200"/>
+            <a:off x="6446520" y="1600200"/>
+            <a:ext cx="457200" cy="457200"/>
           </a:xfrm>
           <a:prstGeom prst="rect">
             <a:avLst/>
@@ -10201,6 +10021,42 @@
           <a:ln/>
         </p:spPr>
         <p:txBody>
+          <a:bodyPr wrap="square" lIns="0" tIns="0" rIns="0" bIns="0" rtlCol="0" anchor="ctr"/>
+          <a:lstStyle/>
+          <a:p>
+            <a:pPr algn="ctr" indent="0" marL="0">
+              <a:buNone/>
+            </a:pPr>
+            <a:r>
+              <a:rPr lang="en-US" sz="1600" b="1" dirty="0">
+                <a:solidFill>
+                  <a:srgbClr val="FFFFFF"/>
+                </a:solidFill>
+              </a:rPr>
+              <a:t>2</a:t>
+            </a:r>
+            <a:endParaRPr lang="en-US" sz="1600" dirty="0"/>
+          </a:p>
+        </p:txBody>
+      </p:sp>
+      <p:sp>
+        <p:nvSpPr>
+          <p:cNvPr id="11" name="Text 9"/>
+          <p:cNvSpPr txBox="1"/>
+          <p:nvPr/>
+        </p:nvSpPr>
+        <p:spPr>
+          <a:xfrm>
+            <a:off x="7086600" y="1627632"/>
+            <a:ext cx="4297680" cy="457200"/>
+          </a:xfrm>
+          <a:prstGeom prst="rect">
+            <a:avLst/>
+          </a:prstGeom>
+          <a:noFill/>
+          <a:ln/>
+        </p:spPr>
+        <p:txBody>
           <a:bodyPr wrap="square" lIns="0" tIns="0" rIns="0" bIns="0" rtlCol="0" anchor="t"/>
           <a:lstStyle/>
           <a:p>
@@ -10208,30 +10064,30 @@
               <a:buNone/>
             </a:pPr>
             <a:r>
-              <a:rPr lang="en-US" sz="2000" b="1" dirty="0">
-                <a:solidFill>
-                  <a:srgbClr val="4E7D32"/>
+              <a:rPr lang="en-US" sz="1900" b="1" dirty="0">
+                <a:solidFill>
+                  <a:srgbClr val="1F1A14"/>
                 </a:solidFill>
                 <a:latin typeface="Cambria" pitchFamily="34" charset="0"/>
                 <a:ea typeface="Cambria" pitchFamily="34" charset="-122"/>
                 <a:cs typeface="Cambria" pitchFamily="34" charset="-120"/>
               </a:rPr>
-              <a:t>No outcome is hard-coded</a:t>
-            </a:r>
-            <a:endParaRPr lang="en-US" sz="2000" dirty="0"/>
-          </a:p>
-        </p:txBody>
-      </p:sp>
-      <p:sp>
-        <p:nvSpPr>
-          <p:cNvPr id="8" name="Text 6"/>
+              <a:t>Suicide or failure?</a:t>
+            </a:r>
+            <a:endParaRPr lang="en-US" sz="1900" dirty="0"/>
+          </a:p>
+        </p:txBody>
+      </p:sp>
+      <p:sp>
+        <p:nvSpPr>
+          <p:cNvPr id="12" name="Text 10"/>
           <p:cNvSpPr txBox="1"/>
           <p:nvPr/>
         </p:nvSpPr>
         <p:spPr>
           <a:xfrm>
-            <a:off x="6492240" y="2011680"/>
-            <a:ext cx="4846320" cy="3840480"/>
+            <a:off x="6446520" y="2240280"/>
+            <a:ext cx="4937760" cy="1280160"/>
           </a:xfrm>
           <a:prstGeom prst="rect">
             <a:avLst/>
@@ -10243,12 +10099,8 @@
           <a:bodyPr wrap="square" lIns="0" tIns="0" rIns="0" bIns="0" rtlCol="0" anchor="t"/>
           <a:lstStyle/>
           <a:p>
-            <a:pPr marL="342900" indent="-342900">
-              <a:spcAft>
-                <a:spcPts val="800"/>
-              </a:spcAft>
-              <a:buSzPct val="100000"/>
-              <a:buChar char="•"/>
+            <a:pPr indent="0" marL="0">
+              <a:buNone/>
             </a:pPr>
             <a:r>
               <a:rPr lang="en-US" sz="1500" dirty="0">
@@ -10256,17 +10108,162 @@
                   <a:srgbClr val="1F1A14"/>
                 </a:solidFill>
               </a:rPr>
-              <a:t>Every death comes from per-organism rules: age, cell damage or hunger</a:t>
+              <a:t>Suicide in the base engine (evolved plant-killers, 3 of 3). Failure to adapt for rhinos and non-adapting zebras; boom-bust for leopards.</a:t>
             </a:r>
             <a:endParaRPr lang="en-US" sz="1500" dirty="0"/>
           </a:p>
-          <a:p>
-            <a:pPr marL="342900" indent="-342900">
-              <a:spcAft>
-                <a:spcPts val="800"/>
-              </a:spcAft>
-              <a:buSzPct val="100000"/>
-              <a:buChar char="•"/>
+        </p:txBody>
+      </p:sp>
+      <p:sp>
+        <p:nvSpPr>
+          <p:cNvPr id="13" name="Shape 11"/>
+          <p:cNvSpPr/>
+          <p:nvPr/>
+        </p:nvSpPr>
+        <p:spPr>
+          <a:xfrm>
+            <a:off x="548640" y="3657600"/>
+            <a:ext cx="5440680" cy="2103120"/>
+          </a:xfrm>
+          <a:prstGeom prst="roundRect">
+            <a:avLst>
+              <a:gd name="adj" fmla="val 5217"/>
+            </a:avLst>
+          </a:prstGeom>
+          <a:solidFill>
+            <a:srgbClr val="F1F3F2"/>
+          </a:solidFill>
+          <a:ln w="12700">
+            <a:solidFill>
+              <a:srgbClr val="F1F3F2"/>
+            </a:solidFill>
+            <a:prstDash val="solid"/>
+          </a:ln>
+        </p:spPr>
+      </p:sp>
+      <p:sp>
+        <p:nvSpPr>
+          <p:cNvPr id="14" name="Shape 12"/>
+          <p:cNvSpPr/>
+          <p:nvPr/>
+        </p:nvSpPr>
+        <p:spPr>
+          <a:xfrm>
+            <a:off x="822960" y="3931920"/>
+            <a:ext cx="457200" cy="457200"/>
+          </a:xfrm>
+          <a:prstGeom prst="ellipse">
+            <a:avLst/>
+          </a:prstGeom>
+          <a:solidFill>
+            <a:srgbClr val="D98E04"/>
+          </a:solidFill>
+          <a:ln w="12700">
+            <a:solidFill>
+              <a:srgbClr val="D98E04"/>
+            </a:solidFill>
+            <a:prstDash val="solid"/>
+          </a:ln>
+        </p:spPr>
+      </p:sp>
+      <p:sp>
+        <p:nvSpPr>
+          <p:cNvPr id="15" name="Text 13"/>
+          <p:cNvSpPr txBox="1"/>
+          <p:nvPr/>
+        </p:nvSpPr>
+        <p:spPr>
+          <a:xfrm>
+            <a:off x="822960" y="3931920"/>
+            <a:ext cx="457200" cy="457200"/>
+          </a:xfrm>
+          <a:prstGeom prst="rect">
+            <a:avLst/>
+          </a:prstGeom>
+          <a:noFill/>
+          <a:ln/>
+        </p:spPr>
+        <p:txBody>
+          <a:bodyPr wrap="square" lIns="0" tIns="0" rIns="0" bIns="0" rtlCol="0" anchor="ctr"/>
+          <a:lstStyle/>
+          <a:p>
+            <a:pPr algn="ctr" indent="0" marL="0">
+              <a:buNone/>
+            </a:pPr>
+            <a:r>
+              <a:rPr lang="en-US" sz="1600" b="1" dirty="0">
+                <a:solidFill>
+                  <a:srgbClr val="FFFFFF"/>
+                </a:solidFill>
+              </a:rPr>
+              <a:t>3</a:t>
+            </a:r>
+            <a:endParaRPr lang="en-US" sz="1600" dirty="0"/>
+          </a:p>
+        </p:txBody>
+      </p:sp>
+      <p:sp>
+        <p:nvSpPr>
+          <p:cNvPr id="16" name="Text 14"/>
+          <p:cNvSpPr txBox="1"/>
+          <p:nvPr/>
+        </p:nvSpPr>
+        <p:spPr>
+          <a:xfrm>
+            <a:off x="1463040" y="3959352"/>
+            <a:ext cx="4297680" cy="457200"/>
+          </a:xfrm>
+          <a:prstGeom prst="rect">
+            <a:avLst/>
+          </a:prstGeom>
+          <a:noFill/>
+          <a:ln/>
+        </p:spPr>
+        <p:txBody>
+          <a:bodyPr wrap="square" lIns="0" tIns="0" rIns="0" bIns="0" rtlCol="0" anchor="t"/>
+          <a:lstStyle/>
+          <a:p>
+            <a:pPr indent="0" marL="0">
+              <a:buNone/>
+            </a:pPr>
+            <a:r>
+              <a:rPr lang="en-US" sz="1900" b="1" dirty="0">
+                <a:solidFill>
+                  <a:srgbClr val="1F1A14"/>
+                </a:solidFill>
+                <a:latin typeface="Cambria" pitchFamily="34" charset="0"/>
+                <a:ea typeface="Cambria" pitchFamily="34" charset="-122"/>
+                <a:cs typeface="Cambria" pitchFamily="34" charset="-120"/>
+              </a:rPr>
+              <a:t>Environment or species?</a:t>
+            </a:r>
+            <a:endParaRPr lang="en-US" sz="1900" dirty="0"/>
+          </a:p>
+        </p:txBody>
+      </p:sp>
+      <p:sp>
+        <p:nvSpPr>
+          <p:cNvPr id="17" name="Text 15"/>
+          <p:cNvSpPr txBox="1"/>
+          <p:nvPr/>
+        </p:nvSpPr>
+        <p:spPr>
+          <a:xfrm>
+            <a:off x="822960" y="4572000"/>
+            <a:ext cx="4937760" cy="1280160"/>
+          </a:xfrm>
+          <a:prstGeom prst="rect">
+            <a:avLst/>
+          </a:prstGeom>
+          <a:noFill/>
+          <a:ln/>
+        </p:spPr>
+        <p:txBody>
+          <a:bodyPr wrap="square" lIns="0" tIns="0" rIns="0" bIns="0" rtlCol="0" anchor="t"/>
+          <a:lstStyle/>
+          <a:p>
+            <a:pPr indent="0" marL="0">
+              <a:buNone/>
             </a:pPr>
             <a:r>
               <a:rPr lang="en-US" sz="1500" dirty="0">
@@ -10274,17 +10271,162 @@
                   <a:srgbClr val="1F1A14"/>
                 </a:solidFill>
               </a:rPr>
-              <a:t>Variants only change starting organisms and settings</a:t>
+              <a:t>The same zebras killed themselves in the base engine and adapted in the savanna. Removing the river or soil water was as decisive as removing a trait.</a:t>
             </a:r>
             <a:endParaRPr lang="en-US" sz="1500" dirty="0"/>
           </a:p>
-          <a:p>
-            <a:pPr marL="342900" indent="-342900">
-              <a:spcAft>
-                <a:spcPts val="800"/>
-              </a:spcAft>
-              <a:buSzPct val="100000"/>
-              <a:buChar char="•"/>
+        </p:txBody>
+      </p:sp>
+      <p:sp>
+        <p:nvSpPr>
+          <p:cNvPr id="18" name="Shape 16"/>
+          <p:cNvSpPr/>
+          <p:nvPr/>
+        </p:nvSpPr>
+        <p:spPr>
+          <a:xfrm>
+            <a:off x="6172200" y="3657600"/>
+            <a:ext cx="5440680" cy="2103120"/>
+          </a:xfrm>
+          <a:prstGeom prst="roundRect">
+            <a:avLst>
+              <a:gd name="adj" fmla="val 5217"/>
+            </a:avLst>
+          </a:prstGeom>
+          <a:solidFill>
+            <a:srgbClr val="F1F3F2"/>
+          </a:solidFill>
+          <a:ln w="12700">
+            <a:solidFill>
+              <a:srgbClr val="F1F3F2"/>
+            </a:solidFill>
+            <a:prstDash val="solid"/>
+          </a:ln>
+        </p:spPr>
+      </p:sp>
+      <p:sp>
+        <p:nvSpPr>
+          <p:cNvPr id="19" name="Shape 17"/>
+          <p:cNvSpPr/>
+          <p:nvPr/>
+        </p:nvSpPr>
+        <p:spPr>
+          <a:xfrm>
+            <a:off x="6446520" y="3931920"/>
+            <a:ext cx="457200" cy="457200"/>
+          </a:xfrm>
+          <a:prstGeom prst="ellipse">
+            <a:avLst/>
+          </a:prstGeom>
+          <a:solidFill>
+            <a:srgbClr val="D98E04"/>
+          </a:solidFill>
+          <a:ln w="12700">
+            <a:solidFill>
+              <a:srgbClr val="D98E04"/>
+            </a:solidFill>
+            <a:prstDash val="solid"/>
+          </a:ln>
+        </p:spPr>
+      </p:sp>
+      <p:sp>
+        <p:nvSpPr>
+          <p:cNvPr id="20" name="Text 18"/>
+          <p:cNvSpPr txBox="1"/>
+          <p:nvPr/>
+        </p:nvSpPr>
+        <p:spPr>
+          <a:xfrm>
+            <a:off x="6446520" y="3931920"/>
+            <a:ext cx="457200" cy="457200"/>
+          </a:xfrm>
+          <a:prstGeom prst="rect">
+            <a:avLst/>
+          </a:prstGeom>
+          <a:noFill/>
+          <a:ln/>
+        </p:spPr>
+        <p:txBody>
+          <a:bodyPr wrap="square" lIns="0" tIns="0" rIns="0" bIns="0" rtlCol="0" anchor="ctr"/>
+          <a:lstStyle/>
+          <a:p>
+            <a:pPr algn="ctr" indent="0" marL="0">
+              <a:buNone/>
+            </a:pPr>
+            <a:r>
+              <a:rPr lang="en-US" sz="1600" b="1" dirty="0">
+                <a:solidFill>
+                  <a:srgbClr val="FFFFFF"/>
+                </a:solidFill>
+              </a:rPr>
+              <a:t>4</a:t>
+            </a:r>
+            <a:endParaRPr lang="en-US" sz="1600" dirty="0"/>
+          </a:p>
+        </p:txBody>
+      </p:sp>
+      <p:sp>
+        <p:nvSpPr>
+          <p:cNvPr id="21" name="Text 19"/>
+          <p:cNvSpPr txBox="1"/>
+          <p:nvPr/>
+        </p:nvSpPr>
+        <p:spPr>
+          <a:xfrm>
+            <a:off x="7086600" y="3959352"/>
+            <a:ext cx="4297680" cy="457200"/>
+          </a:xfrm>
+          <a:prstGeom prst="rect">
+            <a:avLst/>
+          </a:prstGeom>
+          <a:noFill/>
+          <a:ln/>
+        </p:spPr>
+        <p:txBody>
+          <a:bodyPr wrap="square" lIns="0" tIns="0" rIns="0" bIns="0" rtlCol="0" anchor="t"/>
+          <a:lstStyle/>
+          <a:p>
+            <a:pPr indent="0" marL="0">
+              <a:buNone/>
+            </a:pPr>
+            <a:r>
+              <a:rPr lang="en-US" sz="1900" b="1" dirty="0">
+                <a:solidFill>
+                  <a:srgbClr val="1F1A14"/>
+                </a:solidFill>
+                <a:latin typeface="Cambria" pitchFamily="34" charset="0"/>
+                <a:ea typeface="Cambria" pitchFamily="34" charset="-122"/>
+                <a:cs typeface="Cambria" pitchFamily="34" charset="-120"/>
+              </a:rPr>
+              <a:t>Instrumental traits</a:t>
+            </a:r>
+            <a:endParaRPr lang="en-US" sz="1900" dirty="0"/>
+          </a:p>
+        </p:txBody>
+      </p:sp>
+      <p:sp>
+        <p:nvSpPr>
+          <p:cNvPr id="22" name="Text 20"/>
+          <p:cNvSpPr txBox="1"/>
+          <p:nvPr/>
+        </p:nvSpPr>
+        <p:spPr>
+          <a:xfrm>
+            <a:off x="6446520" y="4572000"/>
+            <a:ext cx="4937760" cy="1280160"/>
+          </a:xfrm>
+          <a:prstGeom prst="rect">
+            <a:avLst/>
+          </a:prstGeom>
+          <a:noFill/>
+          <a:ln/>
+        </p:spPr>
+        <p:txBody>
+          <a:bodyPr wrap="square" lIns="0" tIns="0" rIns="0" bIns="0" rtlCol="0" anchor="t"/>
+          <a:lstStyle/>
+          <a:p>
+            <a:pPr indent="0" marL="0">
+              <a:buNone/>
             </a:pPr>
             <a:r>
               <a:rPr lang="en-US" sz="1500" dirty="0">
@@ -10292,25 +10434,7 @@
                   <a:srgbClr val="1F1A14"/>
                 </a:solidFill>
               </a:rPr>
-              <a:t>Seeds of one condition reach different outcomes</a:t>
-            </a:r>
-            <a:endParaRPr lang="en-US" sz="1500" dirty="0"/>
-          </a:p>
-          <a:p>
-            <a:pPr marL="342900" indent="-342900">
-              <a:spcAft>
-                <a:spcPts val="800"/>
-              </a:spcAft>
-              <a:buSzPct val="100000"/>
-              <a:buChar char="•"/>
-            </a:pPr>
-            <a:r>
-              <a:rPr lang="en-US" sz="1500" dirty="0">
-                <a:solidFill>
-                  <a:srgbClr val="1F1A14"/>
-                </a:solidFill>
-              </a:rPr>
-              <a:t>Code: src/Organism/Cell/BodyCells, savanna-experiments/</a:t>
+              <a:t>Toward collapse: evolved killers, costly armour, single-prey diet. Away: river, water regrowth, stripes, kick, the second mouth.</a:t>
             </a:r>
             <a:endParaRPr lang="en-US" sz="1500" dirty="0"/>
           </a:p>
@@ -10372,6 +10496,434 @@
 <file path=ppt/slides/slide17.xml><?xml version="1.0" encoding="utf-8"?>
 <p:sld xmlns:a="http://schemas.openxmlformats.org/drawingml/2006/main" xmlns:r="http://schemas.openxmlformats.org/officeDocument/2006/relationships" xmlns:p="http://schemas.openxmlformats.org/presentationml/2006/main">
   <p:cSld name="Slide 17">
+    <p:spTree>
+      <p:nvGrpSpPr>
+        <p:cNvPr id="1" name=""/>
+        <p:cNvGrpSpPr/>
+        <p:nvPr/>
+      </p:nvGrpSpPr>
+      <p:grpSpPr>
+        <a:xfrm>
+          <a:off x="0" y="0"/>
+          <a:ext cx="0" cy="0"/>
+          <a:chOff x="0" y="0"/>
+          <a:chExt cx="0" cy="0"/>
+        </a:xfrm>
+      </p:grpSpPr>
+      <p:sp>
+        <p:nvSpPr>
+          <p:cNvPr id="2" name="Text 0"/>
+          <p:cNvSpPr/>
+          <p:nvPr>
+            <p:ph idx="100" type="title" hasCustomPrompt="1"/>
+          </p:nvPr>
+        </p:nvSpPr>
+        <p:spPr>
+          <a:xfrm>
+            <a:off x="548640" y="320040"/>
+            <a:ext cx="11064240" cy="777240"/>
+          </a:xfrm>
+          <a:prstGeom prst="rect">
+            <a:avLst/>
+          </a:prstGeom>
+          <a:noFill/>
+          <a:ln/>
+        </p:spPr>
+        <p:txBody>
+          <a:bodyPr wrap="square" rtlCol="0" anchor="t"/>
+          <a:lstStyle/>
+          <a:p>
+            <a:pPr algn="l" indent="0" marL="0">
+              <a:buNone/>
+            </a:pPr>
+            <a:r>
+              <a:rPr lang="en-US" sz="3000" b="1" dirty="0">
+                <a:solidFill>
+                  <a:schemeClr val="tx1"/>
+                </a:solidFill>
+              </a:rPr>
+              <a:t>What we can and cannot claim</a:t>
+            </a:r>
+            <a:endParaRPr lang="en-US" sz="3000" dirty="0"/>
+          </a:p>
+        </p:txBody>
+      </p:sp>
+      <p:sp>
+        <p:nvSpPr>
+          <p:cNvPr id="3" name="Shape 1"/>
+          <p:cNvSpPr/>
+          <p:nvPr/>
+        </p:nvSpPr>
+        <p:spPr>
+          <a:xfrm>
+            <a:off x="548640" y="1280160"/>
+            <a:ext cx="5394960" cy="3840480"/>
+          </a:xfrm>
+          <a:prstGeom prst="roundRect">
+            <a:avLst>
+              <a:gd name="adj" fmla="val 2857"/>
+            </a:avLst>
+          </a:prstGeom>
+          <a:solidFill>
+            <a:srgbClr val="F8ECEC"/>
+          </a:solidFill>
+          <a:ln w="12700">
+            <a:solidFill>
+              <a:srgbClr val="F8ECEC"/>
+            </a:solidFill>
+            <a:prstDash val="solid"/>
+          </a:ln>
+        </p:spPr>
+      </p:sp>
+      <p:sp>
+        <p:nvSpPr>
+          <p:cNvPr id="4" name="Text 2"/>
+          <p:cNvSpPr txBox="1"/>
+          <p:nvPr/>
+        </p:nvSpPr>
+        <p:spPr>
+          <a:xfrm>
+            <a:off x="822960" y="1463040"/>
+            <a:ext cx="4846320" cy="457200"/>
+          </a:xfrm>
+          <a:prstGeom prst="rect">
+            <a:avLst/>
+          </a:prstGeom>
+          <a:noFill/>
+          <a:ln/>
+        </p:spPr>
+        <p:txBody>
+          <a:bodyPr wrap="square" lIns="0" tIns="0" rIns="0" bIns="0" rtlCol="0" anchor="t"/>
+          <a:lstStyle/>
+          <a:p>
+            <a:pPr indent="0" marL="0">
+              <a:buNone/>
+            </a:pPr>
+            <a:r>
+              <a:rPr lang="en-US" sz="2000" b="1" dirty="0">
+                <a:solidFill>
+                  <a:srgbClr val="B23A3A"/>
+                </a:solidFill>
+                <a:latin typeface="Cambria" pitchFamily="34" charset="0"/>
+                <a:ea typeface="Cambria" pitchFamily="34" charset="-122"/>
+                <a:cs typeface="Cambria" pitchFamily="34" charset="-120"/>
+              </a:rPr>
+              <a:t>Limits</a:t>
+            </a:r>
+            <a:endParaRPr lang="en-US" sz="2000" dirty="0"/>
+          </a:p>
+        </p:txBody>
+      </p:sp>
+      <p:sp>
+        <p:nvSpPr>
+          <p:cNvPr id="5" name="Text 3"/>
+          <p:cNvSpPr txBox="1"/>
+          <p:nvPr/>
+        </p:nvSpPr>
+        <p:spPr>
+          <a:xfrm>
+            <a:off x="822960" y="2011680"/>
+            <a:ext cx="4846320" cy="3840480"/>
+          </a:xfrm>
+          <a:prstGeom prst="rect">
+            <a:avLst/>
+          </a:prstGeom>
+          <a:noFill/>
+          <a:ln/>
+        </p:spPr>
+        <p:txBody>
+          <a:bodyPr wrap="square" lIns="0" tIns="0" rIns="0" bIns="0" rtlCol="0" anchor="t"/>
+          <a:lstStyle/>
+          <a:p>
+            <a:pPr marL="342900" indent="-342900">
+              <a:spcAft>
+                <a:spcPts val="800"/>
+              </a:spcAft>
+              <a:buSzPct val="100000"/>
+              <a:buChar char="•"/>
+            </a:pPr>
+            <a:r>
+              <a:rPr lang="en-US" sz="1500" dirty="0">
+                <a:solidFill>
+                  <a:srgbClr val="1F1A14"/>
+                </a:solidFill>
+              </a:rPr>
+              <a:t>3 seeds per ablation and sweep: one seed of difference is noise</a:t>
+            </a:r>
+            <a:endParaRPr lang="en-US" sz="1500" dirty="0"/>
+          </a:p>
+          <a:p>
+            <a:pPr marL="342900" indent="-342900">
+              <a:spcAft>
+                <a:spcPts val="800"/>
+              </a:spcAft>
+              <a:buSzPct val="100000"/>
+              <a:buChar char="•"/>
+            </a:pPr>
+            <a:r>
+              <a:rPr lang="en-US" sz="1500" dirty="0">
+                <a:solidFill>
+                  <a:srgbClr val="1F1A14"/>
+                </a:solidFill>
+              </a:rPr>
+              <a:t>Rules were rebalanced during testing (leopard body, sprint, armour, weapons) before the final runs</a:t>
+            </a:r>
+            <a:endParaRPr lang="en-US" sz="1500" dirty="0"/>
+          </a:p>
+          <a:p>
+            <a:pPr marL="342900" indent="-342900">
+              <a:spcAft>
+                <a:spcPts val="800"/>
+              </a:spcAft>
+              <a:buSzPct val="100000"/>
+              <a:buChar char="•"/>
+            </a:pPr>
+            <a:r>
+              <a:rPr lang="en-US" sz="1500" dirty="0">
+                <a:solidFill>
+                  <a:srgbClr val="1F1A14"/>
+                </a:solidFill>
+              </a:rPr>
+              <a:t>Our overgrazing hypothesis was not observed in 100k ticks</a:t>
+            </a:r>
+            <a:endParaRPr lang="en-US" sz="1500" dirty="0"/>
+          </a:p>
+          <a:p>
+            <a:pPr marL="342900" indent="-342900">
+              <a:spcAft>
+                <a:spcPts val="800"/>
+              </a:spcAft>
+              <a:buSzPct val="100000"/>
+              <a:buChar char="•"/>
+            </a:pPr>
+            <a:r>
+              <a:rPr lang="en-US" sz="1500" dirty="0">
+                <a:solidFill>
+                  <a:srgbClr val="1F1A14"/>
+                </a:solidFill>
+              </a:rPr>
+              <a:t>Fires stayed small and leopards never persisted, even with 10x fire and 3x leopards</a:t>
+            </a:r>
+            <a:endParaRPr lang="en-US" sz="1500" dirty="0"/>
+          </a:p>
+        </p:txBody>
+      </p:sp>
+      <p:sp>
+        <p:nvSpPr>
+          <p:cNvPr id="6" name="Shape 4"/>
+          <p:cNvSpPr/>
+          <p:nvPr/>
+        </p:nvSpPr>
+        <p:spPr>
+          <a:xfrm>
+            <a:off x="6217920" y="1280160"/>
+            <a:ext cx="5394960" cy="3840480"/>
+          </a:xfrm>
+          <a:prstGeom prst="roundRect">
+            <a:avLst>
+              <a:gd name="adj" fmla="val 2857"/>
+            </a:avLst>
+          </a:prstGeom>
+          <a:solidFill>
+            <a:srgbClr val="EEF5EA"/>
+          </a:solidFill>
+          <a:ln w="12700">
+            <a:solidFill>
+              <a:srgbClr val="EEF5EA"/>
+            </a:solidFill>
+            <a:prstDash val="solid"/>
+          </a:ln>
+        </p:spPr>
+      </p:sp>
+      <p:sp>
+        <p:nvSpPr>
+          <p:cNvPr id="7" name="Text 5"/>
+          <p:cNvSpPr txBox="1"/>
+          <p:nvPr/>
+        </p:nvSpPr>
+        <p:spPr>
+          <a:xfrm>
+            <a:off x="6492240" y="1463040"/>
+            <a:ext cx="4846320" cy="457200"/>
+          </a:xfrm>
+          <a:prstGeom prst="rect">
+            <a:avLst/>
+          </a:prstGeom>
+          <a:noFill/>
+          <a:ln/>
+        </p:spPr>
+        <p:txBody>
+          <a:bodyPr wrap="square" lIns="0" tIns="0" rIns="0" bIns="0" rtlCol="0" anchor="t"/>
+          <a:lstStyle/>
+          <a:p>
+            <a:pPr indent="0" marL="0">
+              <a:buNone/>
+            </a:pPr>
+            <a:r>
+              <a:rPr lang="en-US" sz="2000" b="1" dirty="0">
+                <a:solidFill>
+                  <a:srgbClr val="4E7D32"/>
+                </a:solidFill>
+                <a:latin typeface="Cambria" pitchFamily="34" charset="0"/>
+                <a:ea typeface="Cambria" pitchFamily="34" charset="-122"/>
+                <a:cs typeface="Cambria" pitchFamily="34" charset="-120"/>
+              </a:rPr>
+              <a:t>No outcome is hard-coded</a:t>
+            </a:r>
+            <a:endParaRPr lang="en-US" sz="2000" dirty="0"/>
+          </a:p>
+        </p:txBody>
+      </p:sp>
+      <p:sp>
+        <p:nvSpPr>
+          <p:cNvPr id="8" name="Text 6"/>
+          <p:cNvSpPr txBox="1"/>
+          <p:nvPr/>
+        </p:nvSpPr>
+        <p:spPr>
+          <a:xfrm>
+            <a:off x="6492240" y="2011680"/>
+            <a:ext cx="4846320" cy="3840480"/>
+          </a:xfrm>
+          <a:prstGeom prst="rect">
+            <a:avLst/>
+          </a:prstGeom>
+          <a:noFill/>
+          <a:ln/>
+        </p:spPr>
+        <p:txBody>
+          <a:bodyPr wrap="square" lIns="0" tIns="0" rIns="0" bIns="0" rtlCol="0" anchor="t"/>
+          <a:lstStyle/>
+          <a:p>
+            <a:pPr marL="342900" indent="-342900">
+              <a:spcAft>
+                <a:spcPts val="800"/>
+              </a:spcAft>
+              <a:buSzPct val="100000"/>
+              <a:buChar char="•"/>
+            </a:pPr>
+            <a:r>
+              <a:rPr lang="en-US" sz="1500" dirty="0">
+                <a:solidFill>
+                  <a:srgbClr val="1F1A14"/>
+                </a:solidFill>
+              </a:rPr>
+              <a:t>Every death comes from per-organism rules: age, cell damage or hunger</a:t>
+            </a:r>
+            <a:endParaRPr lang="en-US" sz="1500" dirty="0"/>
+          </a:p>
+          <a:p>
+            <a:pPr marL="342900" indent="-342900">
+              <a:spcAft>
+                <a:spcPts val="800"/>
+              </a:spcAft>
+              <a:buSzPct val="100000"/>
+              <a:buChar char="•"/>
+            </a:pPr>
+            <a:r>
+              <a:rPr lang="en-US" sz="1500" dirty="0">
+                <a:solidFill>
+                  <a:srgbClr val="1F1A14"/>
+                </a:solidFill>
+              </a:rPr>
+              <a:t>Variants only change starting organisms and settings</a:t>
+            </a:r>
+            <a:endParaRPr lang="en-US" sz="1500" dirty="0"/>
+          </a:p>
+          <a:p>
+            <a:pPr marL="342900" indent="-342900">
+              <a:spcAft>
+                <a:spcPts val="800"/>
+              </a:spcAft>
+              <a:buSzPct val="100000"/>
+              <a:buChar char="•"/>
+            </a:pPr>
+            <a:r>
+              <a:rPr lang="en-US" sz="1500" dirty="0">
+                <a:solidFill>
+                  <a:srgbClr val="1F1A14"/>
+                </a:solidFill>
+              </a:rPr>
+              <a:t>Seeds of one condition reach different outcomes</a:t>
+            </a:r>
+            <a:endParaRPr lang="en-US" sz="1500" dirty="0"/>
+          </a:p>
+          <a:p>
+            <a:pPr marL="342900" indent="-342900">
+              <a:spcAft>
+                <a:spcPts val="800"/>
+              </a:spcAft>
+              <a:buSzPct val="100000"/>
+              <a:buChar char="•"/>
+            </a:pPr>
+            <a:r>
+              <a:rPr lang="en-US" sz="1500" dirty="0">
+                <a:solidFill>
+                  <a:srgbClr val="1F1A14"/>
+                </a:solidFill>
+              </a:rPr>
+              <a:t>Code: src/Organism/Cell/BodyCells, savanna-experiments/</a:t>
+            </a:r>
+            <a:endParaRPr lang="en-US" sz="1500" dirty="0"/>
+          </a:p>
+        </p:txBody>
+      </p:sp>
+      <p:sp>
+        <p:nvSpPr>
+          <p:cNvPr id="25" name="Slide Number Placeholder 0"/>
+          <p:cNvSpPr>
+            <a:spLocks noGrp="1"/>
+          </p:cNvSpPr>
+          <p:nvPr>
+            <p:ph type="sldNum" sz="quarter" idx="4294967295"/>
+          </p:nvPr>
+        </p:nvSpPr>
+        <p:spPr>
+          <a:xfrm>
+            <a:off x="11338560" y="6400800"/>
+            <a:ext cx="548640" cy="274320"/>
+          </a:xfrm>
+          <a:prstGeom prst="rect">
+            <a:avLst/>
+          </a:prstGeom>
+          <a:extLst>
+            <a:ext uri="{C572A759-6A51-4108-AA02-DFA0A04FC94B}">
+              <ma14:wrappingTextBoxFlag xmlns:ma14="http://schemas.microsoft.com/office/mac/drawingml/2011/main" val="0"/>
+            </a:ext>
+          </a:extLst>
+        </p:spPr>
+        <p:txBody>
+          <a:bodyPr/>
+          <a:lstStyle>
+            <a:lvl1pPr>
+              <a:defRPr sz="1000">
+                <a:solidFill>
+                  <a:srgbClr val="8A8A8A"/>
+                </a:solidFill>
+              </a:defRPr>
+            </a:lvl1pPr>
+          </a:lstStyle>
+          <a:p>
+            <a:pPr algn="l"/>
+            <a:fld id="{F7021451-1387-4CA6-816F-3879F97B5CBC}" type="slidenum">
+              <a:rPr b="0" lang="en-US"/>
+              <a:t>17</a:t>
+            </a:fld>
+            <a:endParaRPr lang="en-US"/>
+          </a:p>
+        </p:txBody>
+      </p:sp>
+    </p:spTree>
+  </p:cSld>
+  <p:clrMapOvr>
+    <a:masterClrMapping/>
+  </p:clrMapOvr>
+</p:sld>
+</file>
+
+<file path=ppt/slides/slide18.xml><?xml version="1.0" encoding="utf-8"?>
+<p:sld xmlns:a="http://schemas.openxmlformats.org/drawingml/2006/main" xmlns:r="http://schemas.openxmlformats.org/officeDocument/2006/relationships" xmlns:p="http://schemas.openxmlformats.org/presentationml/2006/main">
+  <p:cSld name="Slide 18">
     <p:spTree>
       <p:nvGrpSpPr>
         <p:cNvPr id="1" name=""/>

</xml_diff>

<commit_message>
Rewrite report and slides for clarity; tidy deck build script
Report reorganised into introduction, species, base engine and modified
engine sections with the verdict after the evidence. Slide titles made
descriptive. Deck build no longer depends on an external theme helper.
</commit_message>
<xml_diff>
--- a/presentation/Evolutionary-Suicide-LifeEngine.pptx
+++ b/presentation/Evolutionary-Suicide-LifeEngine.pptx
@@ -129,14 +129,14 @@
   <p:extLst>
     <p:ext uri="{521415D9-36F7-43E2-AB2F-B90AF26B5E84}">
       <p14:sectionLst xmlns:p14="http://schemas.microsoft.com/office/powerpoint/2010/main">
-        <p14:section name="Introduction" id="{36c890e5-82d0-11ec-eb59-1fae52ad10e9}">
+        <p14:section name="Introduction" id="{42e264e2-b91b-e612-037f-28ebaef07480}">
           <p14:sldIdLst>
             <p14:sldId id="256"/>
             <p14:sldId id="257"/>
             <p14:sldId id="258"/>
           </p14:sldIdLst>
         </p14:section>
-        <p14:section name="Part 1: base engine" id="{e0d1221d-94e9-3345-5c2e-781176ae950e}">
+        <p14:section name="Part 1: base engine" id="{4bc0ec7f-3cbe-be77-a9f6-5a6c0cc5f5d0}">
           <p14:sldIdLst>
             <p14:sldId id="259"/>
             <p14:sldId id="260"/>
@@ -146,14 +146,14 @@
             <p14:sldId id="264"/>
           </p14:sldIdLst>
         </p14:section>
-        <p14:section name="Part 2: modifications" id="{9f5897f3-41c8-a12c-d8f0-65361e3d49a2}">
+        <p14:section name="Part 2: modifications" id="{2d37ec66-b13b-9405-d637-33d5b863ac1c}">
           <p14:sldIdLst>
             <p14:sldId id="265"/>
             <p14:sldId id="266"/>
             <p14:sldId id="267"/>
           </p14:sldIdLst>
         </p14:section>
-        <p14:section name="Part 2: did we achieve it?" id="{e35a8b50-066b-fa03-c649-211d611d8649}">
+        <p14:section name="Part 2: did we achieve it?" id="{534392a4-7e3d-2b5b-0df6-df51f8ac1af2}">
           <p14:sldIdLst>
             <p14:sldId id="268"/>
             <p14:sldId id="269"/>
@@ -165,7 +165,7 @@
             <p14:sldId id="275"/>
           </p14:sldIdLst>
         </p14:section>
-        <p14:section name="Conclusions" id="{0648a87a-6fbd-6e37-316d-691a3025fe54}">
+        <p14:section name="Conclusions" id="{5010e09e-7039-1d5b-6d0b-4b6bb9a13c7c}">
           <p14:sldIdLst>
             <p14:sldId id="276"/>
             <p14:sldId id="277"/>
@@ -6062,7 +6062,7 @@
           <a:p>
             <a:r>
               <a:rPr lang="en-US" dirty="0"/>
-              <a:t>The modifications closed the base engine road (killers destroying plants and herds) and opened the grazing road. That road needed grass to regrow slower than it was eaten, and in every setting we tried, regrowth or the fallbacks kept up.</a:t>
+              <a:t>Our changes removed the collapse route the base engine used and made overgrazing possible. Overgrazing needs grass to regrow more slowly than it is eaten, and in every setting we tried, regrowth and fallback foods kept pace with the zebras.</a:t>
             </a:r>
             <a:endParaRPr lang="en-US" dirty="0"/>
           </a:p>
@@ -7680,7 +7680,7 @@
               <a:buNone/>
               <a:defRPr lang="en-US" sz="4400" b="1" dirty="0">
                 <a:solidFill>
-                  <a:schemeClr val="bg1"/>
+                  <a:srgbClr val="FFFFFF"/>
                 </a:solidFill>
               </a:defRPr>
             </a:lvl1pPr>
@@ -7692,7 +7692,7 @@
             <a:r>
               <a:rPr lang="en-US" sz="4400" b="1" dirty="0">
                 <a:solidFill>
-                  <a:schemeClr val="bg1"/>
+                  <a:srgbClr val="FFFFFF"/>
                 </a:solidFill>
               </a:rPr>
               <a:t>Title</a:t>
@@ -7727,7 +7727,7 @@
               <a:buNone/>
               <a:defRPr lang="en-US" sz="2000" dirty="0">
                 <a:solidFill>
-                  <a:schemeClr val="accent1"/>
+                  <a:srgbClr val="D98E04"/>
                 </a:solidFill>
               </a:defRPr>
             </a:lvl1pPr>
@@ -7739,7 +7739,7 @@
             <a:r>
               <a:rPr lang="en-US" sz="2000" dirty="0">
                 <a:solidFill>
-                  <a:schemeClr val="accent1"/>
+                  <a:srgbClr val="D98E04"/>
                 </a:solidFill>
               </a:rPr>
               <a:t>Subtitle</a:t>
@@ -7806,7 +7806,7 @@
               <a:buNone/>
               <a:defRPr lang="en-US" sz="4000" b="1" dirty="0">
                 <a:solidFill>
-                  <a:schemeClr val="bg1"/>
+                  <a:srgbClr val="FFFFFF"/>
                 </a:solidFill>
               </a:defRPr>
             </a:lvl1pPr>
@@ -7818,7 +7818,7 @@
             <a:r>
               <a:rPr lang="en-US" sz="4000" b="1" dirty="0">
                 <a:solidFill>
-                  <a:schemeClr val="bg1"/>
+                  <a:srgbClr val="FFFFFF"/>
                 </a:solidFill>
               </a:rPr>
               <a:t>Section</a:t>
@@ -7853,7 +7853,7 @@
               <a:buNone/>
               <a:defRPr lang="en-US" sz="2000" dirty="0">
                 <a:solidFill>
-                  <a:schemeClr val="accent1"/>
+                  <a:srgbClr val="D98E04"/>
                 </a:solidFill>
               </a:defRPr>
             </a:lvl1pPr>
@@ -7865,7 +7865,7 @@
             <a:r>
               <a:rPr lang="en-US" sz="2000" dirty="0">
                 <a:solidFill>
-                  <a:schemeClr val="accent1"/>
+                  <a:srgbClr val="D98E04"/>
                 </a:solidFill>
               </a:rPr>
               <a:t>Subtitle</a:t>
@@ -7932,7 +7932,7 @@
               <a:buNone/>
               <a:defRPr lang="en-US" sz="3000" b="1" dirty="0">
                 <a:solidFill>
-                  <a:schemeClr val="tx1"/>
+                  <a:srgbClr val="1F1A14"/>
                 </a:solidFill>
               </a:defRPr>
             </a:lvl1pPr>
@@ -7944,7 +7944,7 @@
             <a:r>
               <a:rPr lang="en-US" sz="3000" b="1" dirty="0">
                 <a:solidFill>
-                  <a:schemeClr val="tx1"/>
+                  <a:srgbClr val="1F1A14"/>
                 </a:solidFill>
               </a:rPr>
               <a:t>Title</a:t>
@@ -8413,7 +8413,7 @@
             <a:r>
               <a:rPr lang="en-US" sz="4400" b="1" dirty="0">
                 <a:solidFill>
-                  <a:schemeClr val="bg1"/>
+                  <a:srgbClr val="FFFFFF"/>
                 </a:solidFill>
               </a:rPr>
               <a:t>Reproducing Evolutionary Suicide in a Digital Savanna</a:t>
@@ -8451,7 +8451,7 @@
             <a:r>
               <a:rPr lang="en-US" sz="2000" dirty="0">
                 <a:solidFill>
-                  <a:schemeClr val="accent1"/>
+                  <a:srgbClr val="D98E04"/>
                 </a:solidFill>
               </a:rPr>
               <a:t>Zebras, rhinos, leopards, grass and bushes in the Life Engine  ·  115 runs, base vs modified engine</a:t>
@@ -8538,7 +8538,7 @@
             <a:r>
               <a:rPr lang="en-US" sz="4000" b="1" dirty="0">
                 <a:solidFill>
-                  <a:schemeClr val="bg1"/>
+                  <a:srgbClr val="FFFFFF"/>
                 </a:solidFill>
               </a:rPr>
               <a:t>Part 2: what we changed</a:t>
@@ -8576,10 +8576,10 @@
             <a:r>
               <a:rPr lang="en-US" sz="2000" dirty="0">
                 <a:solidFill>
-                  <a:schemeClr val="accent1"/>
-                </a:solidFill>
-              </a:rPr>
-              <a:t>Each change answers a base-engine limit and adds an escape. All default to off.</a:t>
+                  <a:srgbClr val="D98E04"/>
+                </a:solidFill>
+              </a:rPr>
+              <a:t>Changes made to address the limits of the base engine. All are off by default.</a:t>
             </a:r>
             <a:endParaRPr lang="en-US" sz="2000" dirty="0"/>
           </a:p>
@@ -8639,10 +8639,10 @@
             <a:r>
               <a:rPr lang="en-US" sz="3000" b="1" dirty="0">
                 <a:solidFill>
-                  <a:schemeClr val="tx1"/>
-                </a:solidFill>
-              </a:rPr>
-              <a:t>Each change answers a base-engine limit</a:t>
+                  <a:srgbClr val="1F1A14"/>
+                </a:solidFill>
+              </a:rPr>
+              <a:t>Changes we made to the engine</a:t>
             </a:r>
             <a:endParaRPr lang="en-US" sz="3000" dirty="0"/>
           </a:p>
@@ -9917,10 +9917,10 @@
             <a:r>
               <a:rPr lang="en-US" sz="3000" b="1" dirty="0">
                 <a:solidFill>
-                  <a:schemeClr val="tx1"/>
-                </a:solidFill>
-              </a:rPr>
-              <a:t>Each member feature opens a route and an escape</a:t>
+                  <a:srgbClr val="1F1A14"/>
+                </a:solidFill>
+              </a:rPr>
+              <a:t>Member features</a:t>
             </a:r>
             <a:endParaRPr lang="en-US" sz="3000" dirty="0"/>
           </a:p>
@@ -10058,7 +10058,7 @@
                   <a:srgbClr val="B23A3A"/>
                 </a:solidFill>
               </a:rPr>
-              <a:t>Route  </a:t>
+              <a:t>Can lead to collapse:  </a:t>
             </a:r>
             <a:pPr indent="0" marL="0">
               <a:buNone/>
@@ -10105,7 +10105,7 @@
                   <a:srgbClr val="4E7D32"/>
                 </a:solidFill>
               </a:rPr>
-              <a:t>Escape  </a:t>
+              <a:t>Prevents easy collapse:  </a:t>
             </a:r>
             <a:pPr indent="0" marL="0">
               <a:buNone/>
@@ -10254,7 +10254,7 @@
                   <a:srgbClr val="B23A3A"/>
                 </a:solidFill>
               </a:rPr>
-              <a:t>Route  </a:t>
+              <a:t>Can lead to collapse:  </a:t>
             </a:r>
             <a:pPr indent="0" marL="0">
               <a:buNone/>
@@ -10301,7 +10301,7 @@
                   <a:srgbClr val="4E7D32"/>
                 </a:solidFill>
               </a:rPr>
-              <a:t>Escape  </a:t>
+              <a:t>Prevents easy collapse:  </a:t>
             </a:r>
             <a:pPr indent="0" marL="0">
               <a:buNone/>
@@ -10450,7 +10450,7 @@
                   <a:srgbClr val="B23A3A"/>
                 </a:solidFill>
               </a:rPr>
-              <a:t>Route  </a:t>
+              <a:t>Can lead to collapse:  </a:t>
             </a:r>
             <a:pPr indent="0" marL="0">
               <a:buNone/>
@@ -10497,7 +10497,7 @@
                   <a:srgbClr val="4E7D32"/>
                 </a:solidFill>
               </a:rPr>
-              <a:t>Escape  </a:t>
+              <a:t>Prevents easy collapse:  </a:t>
             </a:r>
             <a:pPr indent="0" marL="0">
               <a:buNone/>
@@ -10646,7 +10646,7 @@
                   <a:srgbClr val="B23A3A"/>
                 </a:solidFill>
               </a:rPr>
-              <a:t>Route  </a:t>
+              <a:t>Can lead to collapse:  </a:t>
             </a:r>
             <a:pPr indent="0" marL="0">
               <a:buNone/>
@@ -10693,7 +10693,7 @@
                   <a:srgbClr val="4E7D32"/>
                 </a:solidFill>
               </a:rPr>
-              <a:t>Escape  </a:t>
+              <a:t>Prevents easy collapse:  </a:t>
             </a:r>
             <a:pPr indent="0" marL="0">
               <a:buNone/>
@@ -10809,10 +10809,10 @@
             <a:r>
               <a:rPr lang="en-US" sz="4000" b="1" dirty="0">
                 <a:solidFill>
-                  <a:schemeClr val="bg1"/>
-                </a:solidFill>
-              </a:rPr>
-              <a:t>Part 2: did we achieve it?</a:t>
+                  <a:srgbClr val="FFFFFF"/>
+                </a:solidFill>
+              </a:rPr>
+              <a:t>Part 2: results</a:t>
             </a:r>
             <a:endParaRPr lang="en-US" sz="4000" dirty="0"/>
           </a:p>
@@ -10847,10 +10847,10 @@
             <a:r>
               <a:rPr lang="en-US" sz="2000" dirty="0">
                 <a:solidFill>
-                  <a:schemeClr val="accent1"/>
-                </a:solidFill>
-              </a:rPr>
-              <a:t>Not evolutionary suicide. Failure to adapt and predator boom-bust, yes.</a:t>
+                  <a:srgbClr val="D98E04"/>
+                </a:solidFill>
+              </a:rPr>
+              <a:t>Results of the main runs, ablations, sweeps, mechanism check and follow-up runs</a:t>
             </a:r>
             <a:endParaRPr lang="en-US" sz="2000" dirty="0"/>
           </a:p>
@@ -10910,10 +10910,10 @@
             <a:r>
               <a:rPr lang="en-US" sz="3000" b="1" dirty="0">
                 <a:solidFill>
-                  <a:schemeClr val="tx1"/>
-                </a:solidFill>
-              </a:rPr>
-              <a:t>Modified engine verdict</a:t>
+                  <a:srgbClr val="1F1A14"/>
+                </a:solidFill>
+              </a:rPr>
+              <a:t>What the modified engine produced</a:t>
             </a:r>
             <a:endParaRPr lang="en-US" sz="3000" dirty="0"/>
           </a:p>
@@ -11051,7 +11051,7 @@
                   <a:srgbClr val="1F1A14"/>
                 </a:solidFill>
               </a:rPr>
-              <a:t>Second mouth spread (up to 2.8) but grass never collapsed: water regrowth, bush fallback and the river kept up</a:t>
+              <a:t>Zebras evolved up to 2.8 mouths, but water-limited regrowth, bush food and the river kept grass from collapsing</a:t>
             </a:r>
             <a:endParaRPr lang="en-US" sz="1300" dirty="0"/>
           </a:p>
@@ -11429,7 +11429,7 @@
                   <a:srgbClr val="D98E04"/>
                 </a:solidFill>
               </a:rPr>
-              <a:t>Yes, not suicide</a:t>
+              <a:t>Yes, but not suicide</a:t>
             </a:r>
             <a:endParaRPr lang="en-US" sz="1600" dirty="0"/>
           </a:p>
@@ -11465,7 +11465,7 @@
                   <a:srgbClr val="1F1A14"/>
                 </a:solidFill>
               </a:rPr>
-              <a:t>Boom-bust every time; 48 leopards ate every zebra then starved, set up by density, not an evolved trait</a:t>
+              <a:t>Boom and bust in every run. With 48 leopards they ate every zebra and then starved, caused by starting density rather than an evolved trait</a:t>
             </a:r>
             <a:endParaRPr lang="en-US" sz="1300" dirty="0"/>
           </a:p>
@@ -11708,10 +11708,10 @@
             <a:r>
               <a:rPr lang="en-US" sz="3000" b="1" dirty="0">
                 <a:solidFill>
-                  <a:schemeClr val="tx1"/>
-                </a:solidFill>
-              </a:rPr>
-              <a:t>Seed 1: predators boom and vanish, zebras adapt</a:t>
+                  <a:srgbClr val="1F1A14"/>
+                </a:solidFill>
+              </a:rPr>
+              <a:t>Main run, seed 1</a:t>
             </a:r>
             <a:endParaRPr lang="en-US" sz="3000" dirty="0"/>
           </a:p>
@@ -11840,10 +11840,10 @@
             <a:r>
               <a:rPr lang="en-US" sz="3000" b="1" dirty="0">
                 <a:solidFill>
-                  <a:schemeClr val="tx1"/>
-                </a:solidFill>
-              </a:rPr>
-              <a:t>Every leopard and rhino population died out</a:t>
+                  <a:srgbClr val="1F1A14"/>
+                </a:solidFill>
+              </a:rPr>
+              <a:t>Main runs across five seeds</a:t>
             </a:r>
             <a:endParaRPr lang="en-US" sz="3000" dirty="0"/>
           </a:p>
@@ -12189,10 +12189,10 @@
             <a:r>
               <a:rPr lang="en-US" sz="3000" b="1" dirty="0">
                 <a:solidFill>
-                  <a:schemeClr val="tx1"/>
-                </a:solidFill>
-              </a:rPr>
-              <a:t>Three different ways to disappear</a:t>
+                  <a:srgbClr val="1F1A14"/>
+                </a:solidFill>
+              </a:rPr>
+              <a:t>How each species declined</a:t>
             </a:r>
             <a:endParaRPr lang="en-US" sz="3000" dirty="0"/>
           </a:p>
@@ -12330,7 +12330,7 @@
                   <a:srgbClr val="1F1A14"/>
                 </a:solidFill>
               </a:rPr>
-              <a:t>Killed 57 to 144 zebras per run, then aged out or were kicked to death. Zebras never crashed first: a predator that failed to persist, not over-predation.</a:t>
+              <a:t>Killed 57 to 144 zebras per run, then aged out or were kicked to death. The zebras did not crash first, so the leopards failed to persist rather than over-hunting.</a:t>
             </a:r>
             <a:endParaRPr lang="en-US" sz="1500" dirty="0"/>
           </a:p>
@@ -12711,10 +12711,10 @@
             <a:r>
               <a:rPr lang="en-US" sz="3000" b="1" dirty="0">
                 <a:solidFill>
-                  <a:schemeClr val="tx1"/>
-                </a:solidFill>
-              </a:rPr>
-              <a:t>Without the river or soil water, every zebra lineage died</a:t>
+                  <a:srgbClr val="1F1A14"/>
+                </a:solidFill>
+              </a:rPr>
+              <a:t>Ablations and sweeps</a:t>
             </a:r>
             <a:endParaRPr lang="en-US" sz="3000" dirty="0"/>
           </a:p>
@@ -12851,10 +12851,10 @@
             <a:r>
               <a:rPr lang="en-US" sz="3000" b="1" dirty="0">
                 <a:solidFill>
-                  <a:schemeClr val="tx1"/>
-                </a:solidFill>
-              </a:rPr>
-              <a:t>Zebras streamlined instead of overgrazing</a:t>
+                  <a:srgbClr val="1F1A14"/>
+                </a:solidFill>
+              </a:rPr>
+              <a:t>Mechanism check: how surviving zebras changed</a:t>
             </a:r>
             <a:endParaRPr lang="en-US" sz="3000" dirty="0"/>
           </a:p>
@@ -13035,10 +13035,10 @@
             <a:r>
               <a:rPr lang="en-US" sz="3000" b="1" dirty="0">
                 <a:solidFill>
-                  <a:schemeClr val="tx1"/>
-                </a:solidFill>
-              </a:rPr>
-              <a:t>Suicide needs four things to happen in order</a:t>
+                  <a:srgbClr val="1F1A14"/>
+                </a:solidFill>
+              </a:rPr>
+              <a:t>Our evidence rule for evolutionary suicide</a:t>
             </a:r>
             <a:endParaRPr lang="en-US" sz="3000" dirty="0"/>
           </a:p>
@@ -13867,10 +13867,10 @@
             <a:r>
               <a:rPr lang="en-US" sz="3000" b="1" dirty="0">
                 <a:solidFill>
-                  <a:schemeClr val="tx1"/>
-                </a:solidFill>
-              </a:rPr>
-              <a:t>Longer, drier, more predators, more fire: same verdict</a:t>
+                  <a:srgbClr val="1F1A14"/>
+                </a:solidFill>
+              </a:rPr>
+              <a:t>Follow-up runs</a:t>
             </a:r>
             <a:endParaRPr lang="en-US" sz="3000" dirty="0"/>
           </a:p>
@@ -14329,7 +14329,7 @@
             <a:r>
               <a:rPr lang="en-US" sz="3000" b="1" dirty="0">
                 <a:solidFill>
-                  <a:schemeClr val="tx1"/>
+                  <a:srgbClr val="1F1A14"/>
                 </a:solidFill>
               </a:rPr>
               <a:t>Answers to the brief</a:t>
@@ -14821,7 +14821,7 @@
                   <a:srgbClr val="1F1A14"/>
                 </a:solidFill>
               </a:rPr>
-              <a:t>The engine decided the road: killers in the base engine, grazing in ours. Removing the river or soil water was as decisive as removing a trait.</a:t>
+              <a:t>The engine rules decided how collapse could happen. Removing the river or soil water had as large an effect as removing a species trait.</a:t>
             </a:r>
             <a:endParaRPr lang="en-US" sz="1500" dirty="0"/>
           </a:p>
@@ -15089,10 +15089,10 @@
             <a:r>
               <a:rPr lang="en-US" sz="3000" b="1" dirty="0">
                 <a:solidFill>
-                  <a:schemeClr val="tx1"/>
-                </a:solidFill>
-              </a:rPr>
-              <a:t>What we can and cannot claim</a:t>
+                  <a:srgbClr val="1F1A14"/>
+                </a:solidFill>
+              </a:rPr>
+              <a:t>Limitations</a:t>
             </a:r>
             <a:endParaRPr lang="en-US" sz="3000" dirty="0"/>
           </a:p>
@@ -15535,10 +15535,10 @@
             <a:r>
               <a:rPr lang="en-US" sz="4400" b="1" dirty="0">
                 <a:solidFill>
-                  <a:schemeClr val="bg1"/>
-                </a:solidFill>
-              </a:rPr>
-              <a:t>The trait that wins is not always the trait that kills</a:t>
+                  <a:srgbClr val="FFFFFF"/>
+                </a:solidFill>
+              </a:rPr>
+              <a:t>Conclusion</a:t>
             </a:r>
             <a:endParaRPr lang="en-US" sz="4400" dirty="0"/>
           </a:p>
@@ -15573,10 +15573,10 @@
             <a:r>
               <a:rPr lang="en-US" sz="2000" dirty="0">
                 <a:solidFill>
-                  <a:schemeClr val="accent1"/>
-                </a:solidFill>
-              </a:rPr>
-              <a:t>In the base engine, a killer that paid in food destroyed the plants and the herd. In our savanna, with water, refuges and fallbacks, the same pressure produced adaptation instead.</a:t>
+                  <a:srgbClr val="D98E04"/>
+                </a:solidFill>
+              </a:rPr>
+              <a:t>Evolutionary suicide occurred in the base engine through an evolved killer cell. In the modified engine we saw failure to adapt and predator boom-and-bust, but not the overgrazing suicide we predicted.</a:t>
             </a:r>
             <a:endParaRPr lang="en-US" sz="2000" dirty="0"/>
           </a:p>
@@ -15672,10 +15672,10 @@
             <a:r>
               <a:rPr lang="en-US" sz="3000" b="1" dirty="0">
                 <a:solidFill>
-                  <a:schemeClr val="tx1"/>
-                </a:solidFill>
-              </a:rPr>
-              <a:t>Two versions of each species: base and modified</a:t>
+                  <a:srgbClr val="1F1A14"/>
+                </a:solidFill>
+              </a:rPr>
+              <a:t>Species in the base and modified engine</a:t>
             </a:r>
             <a:endParaRPr lang="en-US" sz="3000" dirty="0"/>
           </a:p>
@@ -16349,7 +16349,7 @@
             <a:r>
               <a:rPr lang="en-US" sz="4000" b="1" dirty="0">
                 <a:solidFill>
-                  <a:schemeClr val="bg1"/>
+                  <a:srgbClr val="FFFFFF"/>
                 </a:solidFill>
               </a:rPr>
               <a:t>Part 1: the base engine</a:t>
@@ -16387,7 +16387,7 @@
             <a:r>
               <a:rPr lang="en-US" sz="2000" dirty="0">
                 <a:solidFill>
-                  <a:schemeClr val="accent1"/>
+                  <a:srgbClr val="D98E04"/>
                 </a:solidFill>
               </a:rPr>
               <a:t>What it can and cannot do, how we tried to get suicide or failure to adapt, and what happened</a:t>
@@ -16450,7 +16450,7 @@
             <a:r>
               <a:rPr lang="en-US" sz="3000" b="1" dirty="0">
                 <a:solidFill>
-                  <a:schemeClr val="tx1"/>
+                  <a:srgbClr val="1F1A14"/>
                 </a:solidFill>
               </a:rPr>
               <a:t>What the base engine can and cannot do</a:t>
@@ -16827,7 +16827,7 @@
                   <a:srgbClr val="3B2F22"/>
                 </a:solidFill>
               </a:rPr>
-              <a:t>So in the base engine the only road to collapse runs through killer cells, and our grazing hypothesis cannot be tested.</a:t>
+              <a:t>In the base engine a species can only destroy its food through killer cells, so our grazing hypothesis cannot be tested.</a:t>
             </a:r>
             <a:endParaRPr lang="en-US" sz="1800" dirty="0"/>
           </a:p>
@@ -16932,7 +16932,7 @@
             <a:r>
               <a:rPr lang="en-US" sz="3000" b="1" dirty="0">
                 <a:solidFill>
-                  <a:schemeClr val="tx1"/>
+                  <a:srgbClr val="1F1A14"/>
                 </a:solidFill>
               </a:rPr>
               <a:t>How we tried to get suicide or failure to adapt</a:t>
@@ -17261,7 +17261,7 @@
                   <a:srgbClr val="444444"/>
                 </a:solidFill>
               </a:rPr>
-              <a:t>Route 1: zebras start without a killer; insta-kill on. Will a plant-killing trait evolve, spread and destroy the food?</a:t>
+              <a:t>Zebras start without a killer; insta-kill on. Will a plant-killing trait evolve, spread and destroy the food?</a:t>
             </a:r>
             <a:endParaRPr lang="en-US" sz="1300" dirty="0"/>
           </a:p>
@@ -17424,7 +17424,7 @@
                   <a:srgbClr val="444444"/>
                 </a:solidFill>
               </a:rPr>
-              <a:t>The same route with the killer given at the start</a:t>
+              <a:t>The same, but zebras start with the killer</a:t>
             </a:r>
             <a:endParaRPr lang="en-US" sz="1300" dirty="0"/>
           </a:p>
@@ -17913,7 +17913,7 @@
                   <a:srgbClr val="444444"/>
                 </a:solidFill>
               </a:rPr>
-              <a:t>Route 2: fast plants, few grazers. Can plants choke on their own food?</a:t>
+              <a:t>Fast plants and few grazers. Can plants choke on their own food?</a:t>
             </a:r>
             <a:endParaRPr lang="en-US" sz="1300" dirty="0"/>
           </a:p>
@@ -18018,10 +18018,10 @@
             <a:r>
               <a:rPr lang="en-US" sz="3000" b="1" dirty="0">
                 <a:solidFill>
-                  <a:schemeClr val="tx1"/>
-                </a:solidFill>
-              </a:rPr>
-              <a:t>When the killer had to evolve, the herd ate its world</a:t>
+                  <a:srgbClr val="1F1A14"/>
+                </a:solidFill>
+              </a:rPr>
+              <a:t>Plant-kill control: an evolved killer destroyed the food supply</a:t>
             </a:r>
             <a:endParaRPr lang="en-US" sz="3000" dirty="0"/>
           </a:p>
@@ -18375,10 +18375,10 @@
             <a:r>
               <a:rPr lang="en-US" sz="3000" b="1" dirty="0">
                 <a:solidFill>
-                  <a:schemeClr val="tx1"/>
-                </a:solidFill>
-              </a:rPr>
-              <a:t>With the kick seeded, zebras destroyed their own world</a:t>
+                  <a:srgbClr val="1F1A14"/>
+                </a:solidFill>
+              </a:rPr>
+              <a:t>Seeded kick: zebras destroyed the plants and their own herd</a:t>
             </a:r>
             <a:endParaRPr lang="en-US" sz="3000" dirty="0"/>
           </a:p>
@@ -18768,10 +18768,10 @@
             <a:r>
               <a:rPr lang="en-US" sz="3000" b="1" dirty="0">
                 <a:solidFill>
-                  <a:schemeClr val="tx1"/>
-                </a:solidFill>
-              </a:rPr>
-              <a:t>Base engine verdict, and why we had to change it</a:t>
+                  <a:srgbClr val="1F1A14"/>
+                </a:solidFill>
+              </a:rPr>
+              <a:t>Base engine results and why we changed the engine</a:t>
             </a:r>
             <a:endParaRPr lang="en-US" sz="3000" dirty="0"/>
           </a:p>
@@ -19011,47 +19011,47 @@
 </file>
 
 <file path=ppt/theme/theme1.xml><?xml version="1.0" encoding="utf-8"?>
-<a:theme xmlns:a="http://schemas.openxmlformats.org/drawingml/2006/main" name="Savanna Dusk">
+<a:theme xmlns:a="http://schemas.openxmlformats.org/drawingml/2006/main" name="Office Theme">
   <a:themeElements>
-    <a:clrScheme name="Savanna Dusk">
+    <a:clrScheme name="Office">
       <a:dk1>
-        <a:srgbClr val="1F1A14"/>
+        <a:sysClr val="windowText" lastClr="000000"/>
       </a:dk1>
       <a:lt1>
-        <a:srgbClr val="FFFFFF"/>
+        <a:sysClr val="window" lastClr="FFFFFF"/>
       </a:lt1>
       <a:dk2>
-        <a:srgbClr val="3B2F22"/>
+        <a:srgbClr val="44546A"/>
       </a:dk2>
       <a:lt2>
-        <a:srgbClr val="F1F3F2"/>
+        <a:srgbClr val="E7E6E6"/>
       </a:lt2>
       <a:accent1>
-        <a:srgbClr val="D98E04"/>
+        <a:srgbClr val="4472C4"/>
       </a:accent1>
       <a:accent2>
-        <a:srgbClr val="4E7D32"/>
+        <a:srgbClr val="ED7D31"/>
       </a:accent2>
       <a:accent3>
-        <a:srgbClr val="2F6FA8"/>
+        <a:srgbClr val="A5A5A5"/>
       </a:accent3>
       <a:accent4>
-        <a:srgbClr val="B23A3A"/>
+        <a:srgbClr val="FFC000"/>
       </a:accent4>
       <a:accent5>
-        <a:srgbClr val="7A5C3E"/>
+        <a:srgbClr val="5B9BD5"/>
       </a:accent5>
       <a:accent6>
-        <a:srgbClr val="6B7280"/>
+        <a:srgbClr val="70AD47"/>
       </a:accent6>
       <a:hlink>
-        <a:srgbClr val="2F6FA8"/>
+        <a:srgbClr val="0563C1"/>
       </a:hlink>
       <a:folHlink>
-        <a:srgbClr val="7A5C3E"/>
+        <a:srgbClr val="954F72"/>
       </a:folHlink>
     </a:clrScheme>
-    <a:fontScheme name="Savanna Dusk">
+    <a:fontScheme name="Office">
       <a:majorFont>
         <a:latin typeface="Cambria"/>
         <a:ea typeface=""/>

</xml_diff>

<commit_message>
Reflect three-member group: soil water is a shared feature
</commit_message>
<xml_diff>
--- a/presentation/Evolutionary-Suicide-LifeEngine.pptx
+++ b/presentation/Evolutionary-Suicide-LifeEngine.pptx
@@ -129,14 +129,14 @@
   <p:extLst>
     <p:ext uri="{521415D9-36F7-43E2-AB2F-B90AF26B5E84}">
       <p14:sectionLst xmlns:p14="http://schemas.microsoft.com/office/powerpoint/2010/main">
-        <p14:section name="Introduction" id="{42e264e2-b91b-e612-037f-28ebaef07480}">
+        <p14:section name="Introduction" id="{0cc29d75-ced2-9247-405b-99de9e7ab41c}">
           <p14:sldIdLst>
             <p14:sldId id="256"/>
             <p14:sldId id="257"/>
             <p14:sldId id="258"/>
           </p14:sldIdLst>
         </p14:section>
-        <p14:section name="Part 1: base engine" id="{4bc0ec7f-3cbe-be77-a9f6-5a6c0cc5f5d0}">
+        <p14:section name="Part 1: base engine" id="{b3468cb0-1212-3e77-3168-4d197ebaba88}">
           <p14:sldIdLst>
             <p14:sldId id="259"/>
             <p14:sldId id="260"/>
@@ -146,14 +146,14 @@
             <p14:sldId id="264"/>
           </p14:sldIdLst>
         </p14:section>
-        <p14:section name="Part 2: modifications" id="{2d37ec66-b13b-9405-d637-33d5b863ac1c}">
+        <p14:section name="Part 2: modifications" id="{7ed82594-8c81-e4e4-363a-86ea79abdf3a}">
           <p14:sldIdLst>
             <p14:sldId id="265"/>
             <p14:sldId id="266"/>
             <p14:sldId id="267"/>
           </p14:sldIdLst>
         </p14:section>
-        <p14:section name="Part 2: did we achieve it?" id="{534392a4-7e3d-2b5b-0df6-df51f8ac1af2}">
+        <p14:section name="Part 2: did we achieve it?" id="{815bdb83-2d85-669d-a802-a15e9abf0f7f}">
           <p14:sldIdLst>
             <p14:sldId id="268"/>
             <p14:sldId id="269"/>
@@ -165,7 +165,7 @@
             <p14:sldId id="275"/>
           </p14:sldIdLst>
         </p14:section>
-        <p14:section name="Conclusions" id="{5010e09e-7039-1d5b-6d0b-4b6bb9a13c7c}">
+        <p14:section name="Conclusions" id="{5fec4b0a-fa63-9859-82a9-4b76ec74a627}">
           <p14:sldIdLst>
             <p14:sldId id="276"/>
             <p14:sldId id="277"/>
@@ -10610,7 +10610,7 @@
                   <a:srgbClr val="666666"/>
                 </a:solidFill>
               </a:rPr>
-              <a:t>Fourth member</a:t>
+              <a:t>Shared (group)</a:t>
             </a:r>
             <a:endParaRPr lang="en-US" sz="1300" dirty="0"/>
           </a:p>

</xml_diff>